<commit_message>
Upgrade presentation to Full HD 1920x1080px resolution
Updated the PowerPoint presentation from 960x540px to 1920x1080px (Full HD) while maintaining all content and design.

Changes:
- Defined custom layout for 1920x1080px (20" x 11.25" at 96 DPI)
- Added scaling system with SCALE=2 constant and s() helper function
- Automatically scaled all coordinates (x, y, w, h) by 2x
- Updated README to reflect Full HD resolution
- Preserved all design elements, colors, and typography
- Added scale-coords.js utility script for coordinate transformation

All 17 slides now render at full 1920x1080 resolution for maximum visual quality in presentations.
</commit_message>
<xml_diff>
--- a/presentation/mallacoota-beauty-pivot.pptx
+++ b/presentation/mallacoota-beauty-pivot.pptx
@@ -26,8 +26,8 @@
   <p:notesMasterIdLst>
     <p:notesMasterId r:id="rId19"/>
   </p:notesMasterIdLst>
-  <p:sldSz cx="9144000" cy="5143500"/>
-  <p:notesSz cx="5143500" cy="9144000"/>
+  <p:sldSz cx="18288000" cy="10287000"/>
+  <p:notesSz cx="10287000" cy="18288000"/>
   <p:defaultTextStyle>
     <a:lvl1pPr marL="0" algn="l" defTabSz="914400" rtl="0" eaLnBrk="1" latinLnBrk="0" hangingPunct="1">
       <a:defRPr sz="1800" kern="1200">
@@ -2307,8 +2307,8 @@
         </p:nvSpPr>
         <p:spPr>
           <a:xfrm>
-            <a:off x="457200" y="1371600"/>
-            <a:ext cx="8229600" cy="1371600"/>
+            <a:off x="914400" y="2743200"/>
+            <a:ext cx="16459200" cy="2743200"/>
           </a:xfrm>
           <a:prstGeom prst="rect">
             <a:avLst/>
@@ -2357,8 +2357,8 @@
         </p:nvSpPr>
         <p:spPr>
           <a:xfrm>
-            <a:off x="3657600" y="2834640"/>
-            <a:ext cx="1828800" cy="45720"/>
+            <a:off x="7315200" y="5669280"/>
+            <a:ext cx="3657600" cy="91440"/>
           </a:xfrm>
           <a:prstGeom prst="rect">
             <a:avLst/>
@@ -2377,8 +2377,8 @@
         </p:nvSpPr>
         <p:spPr>
           <a:xfrm>
-            <a:off x="457200" y="3108960"/>
-            <a:ext cx="8229600" cy="731520"/>
+            <a:off x="914400" y="6217920"/>
+            <a:ext cx="16459200" cy="1463040"/>
           </a:xfrm>
           <a:prstGeom prst="rect">
             <a:avLst/>
@@ -2427,8 +2427,8 @@
         </p:nvSpPr>
         <p:spPr>
           <a:xfrm>
-            <a:off x="457200" y="4114800"/>
-            <a:ext cx="8229600" cy="274320"/>
+            <a:off x="914400" y="8229600"/>
+            <a:ext cx="16459200" cy="548640"/>
           </a:xfrm>
           <a:prstGeom prst="rect">
             <a:avLst/>
@@ -2463,8 +2463,8 @@
         </p:nvSpPr>
         <p:spPr>
           <a:xfrm>
-            <a:off x="457200" y="4480560"/>
-            <a:ext cx="8229600" cy="365760"/>
+            <a:off x="914400" y="8961120"/>
+            <a:ext cx="16459200" cy="731520"/>
           </a:xfrm>
           <a:prstGeom prst="rect">
             <a:avLst/>
@@ -2532,7 +2532,7 @@
         <p:spPr>
           <a:xfrm>
             <a:off x="0" y="0"/>
-            <a:ext cx="9144000" cy="731520"/>
+            <a:ext cx="18288000" cy="1463040"/>
           </a:xfrm>
           <a:prstGeom prst="rect">
             <a:avLst/>
@@ -2551,8 +2551,8 @@
         </p:nvSpPr>
         <p:spPr>
           <a:xfrm>
-            <a:off x="457200" y="182880"/>
-            <a:ext cx="8229600" cy="365760"/>
+            <a:off x="914400" y="365760"/>
+            <a:ext cx="16459200" cy="731520"/>
           </a:xfrm>
           <a:prstGeom prst="rect">
             <a:avLst/>
@@ -2587,8 +2587,8 @@
         </p:nvSpPr>
         <p:spPr>
           <a:xfrm>
-            <a:off x="640080" y="1005840"/>
-            <a:ext cx="7863840" cy="228600"/>
+            <a:off x="1280160" y="2011680"/>
+            <a:ext cx="15727680" cy="457200"/>
           </a:xfrm>
           <a:prstGeom prst="rect">
             <a:avLst/>
@@ -2623,8 +2623,8 @@
         </p:nvSpPr>
         <p:spPr>
           <a:xfrm>
-            <a:off x="640080" y="1252728"/>
-            <a:ext cx="7863840" cy="182880"/>
+            <a:off x="1280160" y="2505456"/>
+            <a:ext cx="15727680" cy="365760"/>
           </a:xfrm>
           <a:prstGeom prst="rect">
             <a:avLst/>
@@ -2659,8 +2659,8 @@
         </p:nvSpPr>
         <p:spPr>
           <a:xfrm>
-            <a:off x="640080" y="1554480"/>
-            <a:ext cx="7863840" cy="228600"/>
+            <a:off x="1280160" y="2560320"/>
+            <a:ext cx="15727680" cy="457200"/>
           </a:xfrm>
           <a:prstGeom prst="rect">
             <a:avLst/>
@@ -2695,8 +2695,8 @@
         </p:nvSpPr>
         <p:spPr>
           <a:xfrm>
-            <a:off x="640080" y="1801368"/>
-            <a:ext cx="7863840" cy="182880"/>
+            <a:off x="1280160" y="3054096"/>
+            <a:ext cx="15727680" cy="365760"/>
           </a:xfrm>
           <a:prstGeom prst="rect">
             <a:avLst/>
@@ -2731,8 +2731,8 @@
         </p:nvSpPr>
         <p:spPr>
           <a:xfrm>
-            <a:off x="640080" y="2103120"/>
-            <a:ext cx="7863840" cy="228600"/>
+            <a:off x="1280160" y="3108960"/>
+            <a:ext cx="15727680" cy="457200"/>
           </a:xfrm>
           <a:prstGeom prst="rect">
             <a:avLst/>
@@ -2767,8 +2767,8 @@
         </p:nvSpPr>
         <p:spPr>
           <a:xfrm>
-            <a:off x="640080" y="2350008"/>
-            <a:ext cx="7863840" cy="182880"/>
+            <a:off x="1280160" y="3602736"/>
+            <a:ext cx="15727680" cy="365760"/>
           </a:xfrm>
           <a:prstGeom prst="rect">
             <a:avLst/>
@@ -2803,8 +2803,8 @@
         </p:nvSpPr>
         <p:spPr>
           <a:xfrm>
-            <a:off x="2286000" y="2743200"/>
-            <a:ext cx="4572000" cy="822960"/>
+            <a:off x="4572000" y="5486400"/>
+            <a:ext cx="9144000" cy="1645920"/>
           </a:xfrm>
           <a:prstGeom prst="rect">
             <a:avLst/>
@@ -2823,8 +2823,8 @@
         </p:nvSpPr>
         <p:spPr>
           <a:xfrm>
-            <a:off x="2286000" y="2834640"/>
-            <a:ext cx="4572000" cy="274320"/>
+            <a:off x="4572000" y="5669280"/>
+            <a:ext cx="9144000" cy="548640"/>
           </a:xfrm>
           <a:prstGeom prst="rect">
             <a:avLst/>
@@ -2859,8 +2859,8 @@
         </p:nvSpPr>
         <p:spPr>
           <a:xfrm>
-            <a:off x="2286000" y="3154680"/>
-            <a:ext cx="4572000" cy="228600"/>
+            <a:off x="4572000" y="6309360"/>
+            <a:ext cx="9144000" cy="457200"/>
           </a:xfrm>
           <a:prstGeom prst="rect">
             <a:avLst/>
@@ -2895,8 +2895,8 @@
         </p:nvSpPr>
         <p:spPr>
           <a:xfrm>
-            <a:off x="2286000" y="3749040"/>
-            <a:ext cx="4572000" cy="274320"/>
+            <a:off x="4572000" y="7498080"/>
+            <a:ext cx="9144000" cy="548640"/>
           </a:xfrm>
           <a:prstGeom prst="rect">
             <a:avLst/>
@@ -2964,7 +2964,7 @@
         <p:spPr>
           <a:xfrm>
             <a:off x="0" y="0"/>
-            <a:ext cx="9144000" cy="731520"/>
+            <a:ext cx="18288000" cy="1463040"/>
           </a:xfrm>
           <a:prstGeom prst="rect">
             <a:avLst/>
@@ -2983,8 +2983,8 @@
         </p:nvSpPr>
         <p:spPr>
           <a:xfrm>
-            <a:off x="457200" y="182880"/>
-            <a:ext cx="8229600" cy="365760"/>
+            <a:off x="914400" y="365760"/>
+            <a:ext cx="16459200" cy="731520"/>
           </a:xfrm>
           <a:prstGeom prst="rect">
             <a:avLst/>
@@ -3019,8 +3019,8 @@
         </p:nvSpPr>
         <p:spPr>
           <a:xfrm>
-            <a:off x="914400" y="914400"/>
-            <a:ext cx="7315200" cy="731520"/>
+            <a:off x="1828800" y="1828800"/>
+            <a:ext cx="14630400" cy="1463040"/>
           </a:xfrm>
           <a:prstGeom prst="rect">
             <a:avLst/>
@@ -3028,7 +3028,7 @@
           <a:solidFill>
             <a:srgbClr val="003366"/>
           </a:solidFill>
-          <a:ln w="38100">
+          <a:ln w="76200">
             <a:solidFill>
               <a:srgbClr val="D4AF37"/>
             </a:solidFill>
@@ -3044,8 +3044,8 @@
         </p:nvSpPr>
         <p:spPr>
           <a:xfrm>
-            <a:off x="914400" y="960120"/>
-            <a:ext cx="7315200" cy="182880"/>
+            <a:off x="1828800" y="1920240"/>
+            <a:ext cx="14630400" cy="365760"/>
           </a:xfrm>
           <a:prstGeom prst="rect">
             <a:avLst/>
@@ -3080,8 +3080,8 @@
         </p:nvSpPr>
         <p:spPr>
           <a:xfrm>
-            <a:off x="914400" y="1188720"/>
-            <a:ext cx="7315200" cy="411480"/>
+            <a:off x="1828800" y="2377440"/>
+            <a:ext cx="14630400" cy="822960"/>
           </a:xfrm>
           <a:prstGeom prst="rect">
             <a:avLst/>
@@ -3130,8 +3130,8 @@
         </p:nvSpPr>
         <p:spPr>
           <a:xfrm>
-            <a:off x="457200" y="1828800"/>
-            <a:ext cx="3886200" cy="731520"/>
+            <a:off x="914400" y="3657600"/>
+            <a:ext cx="7772400" cy="1463040"/>
           </a:xfrm>
           <a:prstGeom prst="rect">
             <a:avLst/>
@@ -3139,7 +3139,7 @@
           <a:solidFill>
             <a:srgbClr val="FFFFFF"/>
           </a:solidFill>
-          <a:ln w="25400">
+          <a:ln w="50800">
             <a:solidFill>
               <a:srgbClr val="7FCDCD"/>
             </a:solidFill>
@@ -3155,8 +3155,8 @@
         </p:nvSpPr>
         <p:spPr>
           <a:xfrm>
-            <a:off x="640080" y="1920240"/>
-            <a:ext cx="3520440" cy="228600"/>
+            <a:off x="1097280" y="3749040"/>
+            <a:ext cx="7040880" cy="457200"/>
           </a:xfrm>
           <a:prstGeom prst="rect">
             <a:avLst/>
@@ -3191,8 +3191,8 @@
         </p:nvSpPr>
         <p:spPr>
           <a:xfrm>
-            <a:off x="640080" y="2176272"/>
-            <a:ext cx="3520440" cy="320040"/>
+            <a:off x="1097280" y="4005072"/>
+            <a:ext cx="7040880" cy="640080"/>
           </a:xfrm>
           <a:prstGeom prst="rect">
             <a:avLst/>
@@ -3227,8 +3227,8 @@
         </p:nvSpPr>
         <p:spPr>
           <a:xfrm>
-            <a:off x="4572000" y="1828800"/>
-            <a:ext cx="3886200" cy="731520"/>
+            <a:off x="9144000" y="3657600"/>
+            <a:ext cx="7772400" cy="1463040"/>
           </a:xfrm>
           <a:prstGeom prst="rect">
             <a:avLst/>
@@ -3236,7 +3236,7 @@
           <a:solidFill>
             <a:srgbClr val="FFFFFF"/>
           </a:solidFill>
-          <a:ln w="25400">
+          <a:ln w="50800">
             <a:solidFill>
               <a:srgbClr val="7FCDCD"/>
             </a:solidFill>
@@ -3252,8 +3252,8 @@
         </p:nvSpPr>
         <p:spPr>
           <a:xfrm>
-            <a:off x="4754880" y="1920240"/>
-            <a:ext cx="3520440" cy="228600"/>
+            <a:off x="9326880" y="3749040"/>
+            <a:ext cx="7040880" cy="457200"/>
           </a:xfrm>
           <a:prstGeom prst="rect">
             <a:avLst/>
@@ -3288,8 +3288,8 @@
         </p:nvSpPr>
         <p:spPr>
           <a:xfrm>
-            <a:off x="4754880" y="2176272"/>
-            <a:ext cx="3520440" cy="320040"/>
+            <a:off x="9326880" y="4005072"/>
+            <a:ext cx="7040880" cy="640080"/>
           </a:xfrm>
           <a:prstGeom prst="rect">
             <a:avLst/>
@@ -3324,8 +3324,8 @@
         </p:nvSpPr>
         <p:spPr>
           <a:xfrm>
-            <a:off x="457200" y="2743200"/>
-            <a:ext cx="3886200" cy="731520"/>
+            <a:off x="914400" y="5486400"/>
+            <a:ext cx="7772400" cy="1463040"/>
           </a:xfrm>
           <a:prstGeom prst="rect">
             <a:avLst/>
@@ -3333,7 +3333,7 @@
           <a:solidFill>
             <a:srgbClr val="FFFFFF"/>
           </a:solidFill>
-          <a:ln w="25400">
+          <a:ln w="50800">
             <a:solidFill>
               <a:srgbClr val="7FCDCD"/>
             </a:solidFill>
@@ -3349,8 +3349,8 @@
         </p:nvSpPr>
         <p:spPr>
           <a:xfrm>
-            <a:off x="640080" y="2834640"/>
-            <a:ext cx="3520440" cy="228600"/>
+            <a:off x="1097280" y="5577840"/>
+            <a:ext cx="7040880" cy="457200"/>
           </a:xfrm>
           <a:prstGeom prst="rect">
             <a:avLst/>
@@ -3385,8 +3385,8 @@
         </p:nvSpPr>
         <p:spPr>
           <a:xfrm>
-            <a:off x="640080" y="3090672"/>
-            <a:ext cx="3520440" cy="320040"/>
+            <a:off x="1097280" y="5833872"/>
+            <a:ext cx="7040880" cy="640080"/>
           </a:xfrm>
           <a:prstGeom prst="rect">
             <a:avLst/>
@@ -3421,8 +3421,8 @@
         </p:nvSpPr>
         <p:spPr>
           <a:xfrm>
-            <a:off x="4572000" y="2743200"/>
-            <a:ext cx="3886200" cy="731520"/>
+            <a:off x="9144000" y="5486400"/>
+            <a:ext cx="7772400" cy="1463040"/>
           </a:xfrm>
           <a:prstGeom prst="rect">
             <a:avLst/>
@@ -3430,7 +3430,7 @@
           <a:solidFill>
             <a:srgbClr val="FFFFFF"/>
           </a:solidFill>
-          <a:ln w="25400">
+          <a:ln w="50800">
             <a:solidFill>
               <a:srgbClr val="7FCDCD"/>
             </a:solidFill>
@@ -3446,8 +3446,8 @@
         </p:nvSpPr>
         <p:spPr>
           <a:xfrm>
-            <a:off x="4754880" y="2834640"/>
-            <a:ext cx="3520440" cy="228600"/>
+            <a:off x="9326880" y="5577840"/>
+            <a:ext cx="7040880" cy="457200"/>
           </a:xfrm>
           <a:prstGeom prst="rect">
             <a:avLst/>
@@ -3482,8 +3482,8 @@
         </p:nvSpPr>
         <p:spPr>
           <a:xfrm>
-            <a:off x="4754880" y="3090672"/>
-            <a:ext cx="3520440" cy="320040"/>
+            <a:off x="9326880" y="5833872"/>
+            <a:ext cx="7040880" cy="640080"/>
           </a:xfrm>
           <a:prstGeom prst="rect">
             <a:avLst/>
@@ -3518,8 +3518,8 @@
         </p:nvSpPr>
         <p:spPr>
           <a:xfrm>
-            <a:off x="1828800" y="3657600"/>
-            <a:ext cx="5486400" cy="548640"/>
+            <a:off x="3657600" y="7315200"/>
+            <a:ext cx="10972800" cy="1097280"/>
           </a:xfrm>
           <a:prstGeom prst="rect">
             <a:avLst/>
@@ -3538,8 +3538,8 @@
         </p:nvSpPr>
         <p:spPr>
           <a:xfrm>
-            <a:off x="1828800" y="3749040"/>
-            <a:ext cx="5486400" cy="365760"/>
+            <a:off x="3657600" y="7498080"/>
+            <a:ext cx="10972800" cy="731520"/>
           </a:xfrm>
           <a:prstGeom prst="rect">
             <a:avLst/>
@@ -3607,7 +3607,7 @@
         <p:spPr>
           <a:xfrm>
             <a:off x="0" y="0"/>
-            <a:ext cx="9144000" cy="731520"/>
+            <a:ext cx="18288000" cy="1463040"/>
           </a:xfrm>
           <a:prstGeom prst="rect">
             <a:avLst/>
@@ -3626,8 +3626,8 @@
         </p:nvSpPr>
         <p:spPr>
           <a:xfrm>
-            <a:off x="457200" y="182880"/>
-            <a:ext cx="8229600" cy="365760"/>
+            <a:off x="914400" y="365760"/>
+            <a:ext cx="16459200" cy="731520"/>
           </a:xfrm>
           <a:prstGeom prst="rect">
             <a:avLst/>
@@ -3662,8 +3662,8 @@
         </p:nvSpPr>
         <p:spPr>
           <a:xfrm>
-            <a:off x="457200" y="914400"/>
-            <a:ext cx="8229600" cy="365760"/>
+            <a:off x="914400" y="1828800"/>
+            <a:ext cx="16459200" cy="731520"/>
           </a:xfrm>
           <a:prstGeom prst="rect">
             <a:avLst/>
@@ -3682,8 +3682,8 @@
         </p:nvSpPr>
         <p:spPr>
           <a:xfrm>
-            <a:off x="548640" y="1005840"/>
-            <a:ext cx="914400" cy="182880"/>
+            <a:off x="1097280" y="2011680"/>
+            <a:ext cx="1828800" cy="365760"/>
           </a:xfrm>
           <a:prstGeom prst="rect">
             <a:avLst/>
@@ -3718,8 +3718,8 @@
         </p:nvSpPr>
         <p:spPr>
           <a:xfrm>
-            <a:off x="1828800" y="1005840"/>
-            <a:ext cx="2286000" cy="182880"/>
+            <a:off x="3657600" y="2011680"/>
+            <a:ext cx="4572000" cy="365760"/>
           </a:xfrm>
           <a:prstGeom prst="rect">
             <a:avLst/>
@@ -3754,8 +3754,8 @@
         </p:nvSpPr>
         <p:spPr>
           <a:xfrm>
-            <a:off x="4389120" y="1005840"/>
-            <a:ext cx="1828800" cy="182880"/>
+            <a:off x="8778240" y="2011680"/>
+            <a:ext cx="3657600" cy="365760"/>
           </a:xfrm>
           <a:prstGeom prst="rect">
             <a:avLst/>
@@ -3790,8 +3790,8 @@
         </p:nvSpPr>
         <p:spPr>
           <a:xfrm>
-            <a:off x="6492240" y="1005840"/>
-            <a:ext cx="1828800" cy="182880"/>
+            <a:off x="12984480" y="2011680"/>
+            <a:ext cx="3657600" cy="365760"/>
           </a:xfrm>
           <a:prstGeom prst="rect">
             <a:avLst/>
@@ -3826,8 +3826,8 @@
         </p:nvSpPr>
         <p:spPr>
           <a:xfrm>
-            <a:off x="548640" y="1371600"/>
-            <a:ext cx="914400" cy="274320"/>
+            <a:off x="1097280" y="2743200"/>
+            <a:ext cx="1828800" cy="548640"/>
           </a:xfrm>
           <a:prstGeom prst="rect">
             <a:avLst/>
@@ -3862,8 +3862,8 @@
         </p:nvSpPr>
         <p:spPr>
           <a:xfrm>
-            <a:off x="1828800" y="1371600"/>
-            <a:ext cx="2286000" cy="274320"/>
+            <a:off x="3657600" y="2743200"/>
+            <a:ext cx="4572000" cy="548640"/>
           </a:xfrm>
           <a:prstGeom prst="rect">
             <a:avLst/>
@@ -3898,8 +3898,8 @@
         </p:nvSpPr>
         <p:spPr>
           <a:xfrm>
-            <a:off x="4389120" y="1371600"/>
-            <a:ext cx="1828800" cy="274320"/>
+            <a:off x="8778240" y="2743200"/>
+            <a:ext cx="3657600" cy="548640"/>
           </a:xfrm>
           <a:prstGeom prst="rect">
             <a:avLst/>
@@ -3934,8 +3934,8 @@
         </p:nvSpPr>
         <p:spPr>
           <a:xfrm>
-            <a:off x="6492240" y="1371600"/>
-            <a:ext cx="1828800" cy="274320"/>
+            <a:off x="12984480" y="2743200"/>
+            <a:ext cx="3657600" cy="548640"/>
           </a:xfrm>
           <a:prstGeom prst="rect">
             <a:avLst/>
@@ -3970,8 +3970,8 @@
         </p:nvSpPr>
         <p:spPr>
           <a:xfrm>
-            <a:off x="548640" y="1828800"/>
-            <a:ext cx="914400" cy="274320"/>
+            <a:off x="1097280" y="3657600"/>
+            <a:ext cx="1828800" cy="548640"/>
           </a:xfrm>
           <a:prstGeom prst="rect">
             <a:avLst/>
@@ -4006,8 +4006,8 @@
         </p:nvSpPr>
         <p:spPr>
           <a:xfrm>
-            <a:off x="1828800" y="1828800"/>
-            <a:ext cx="2286000" cy="274320"/>
+            <a:off x="3657600" y="3657600"/>
+            <a:ext cx="4572000" cy="548640"/>
           </a:xfrm>
           <a:prstGeom prst="rect">
             <a:avLst/>
@@ -4042,8 +4042,8 @@
         </p:nvSpPr>
         <p:spPr>
           <a:xfrm>
-            <a:off x="4389120" y="1828800"/>
-            <a:ext cx="1828800" cy="274320"/>
+            <a:off x="8778240" y="3657600"/>
+            <a:ext cx="3657600" cy="548640"/>
           </a:xfrm>
           <a:prstGeom prst="rect">
             <a:avLst/>
@@ -4078,8 +4078,8 @@
         </p:nvSpPr>
         <p:spPr>
           <a:xfrm>
-            <a:off x="6492240" y="1828800"/>
-            <a:ext cx="1828800" cy="274320"/>
+            <a:off x="12984480" y="3657600"/>
+            <a:ext cx="3657600" cy="548640"/>
           </a:xfrm>
           <a:prstGeom prst="rect">
             <a:avLst/>
@@ -4114,8 +4114,8 @@
         </p:nvSpPr>
         <p:spPr>
           <a:xfrm>
-            <a:off x="548640" y="2286000"/>
-            <a:ext cx="914400" cy="274320"/>
+            <a:off x="1097280" y="4572000"/>
+            <a:ext cx="1828800" cy="548640"/>
           </a:xfrm>
           <a:prstGeom prst="rect">
             <a:avLst/>
@@ -4150,8 +4150,8 @@
         </p:nvSpPr>
         <p:spPr>
           <a:xfrm>
-            <a:off x="1828800" y="2286000"/>
-            <a:ext cx="2286000" cy="274320"/>
+            <a:off x="3657600" y="4572000"/>
+            <a:ext cx="4572000" cy="548640"/>
           </a:xfrm>
           <a:prstGeom prst="rect">
             <a:avLst/>
@@ -4186,8 +4186,8 @@
         </p:nvSpPr>
         <p:spPr>
           <a:xfrm>
-            <a:off x="4389120" y="2286000"/>
-            <a:ext cx="1828800" cy="274320"/>
+            <a:off x="8778240" y="4572000"/>
+            <a:ext cx="3657600" cy="548640"/>
           </a:xfrm>
           <a:prstGeom prst="rect">
             <a:avLst/>
@@ -4222,8 +4222,8 @@
         </p:nvSpPr>
         <p:spPr>
           <a:xfrm>
-            <a:off x="6492240" y="2286000"/>
-            <a:ext cx="1828800" cy="274320"/>
+            <a:off x="12984480" y="4572000"/>
+            <a:ext cx="3657600" cy="548640"/>
           </a:xfrm>
           <a:prstGeom prst="rect">
             <a:avLst/>
@@ -4258,8 +4258,8 @@
         </p:nvSpPr>
         <p:spPr>
           <a:xfrm>
-            <a:off x="5029200" y="2926080"/>
-            <a:ext cx="3657600" cy="1097280"/>
+            <a:off x="10058400" y="5852160"/>
+            <a:ext cx="7315200" cy="2194560"/>
           </a:xfrm>
           <a:prstGeom prst="rect">
             <a:avLst/>
@@ -4278,8 +4278,8 @@
         </p:nvSpPr>
         <p:spPr>
           <a:xfrm>
-            <a:off x="5029200" y="3017520"/>
-            <a:ext cx="3657600" cy="228600"/>
+            <a:off x="10058400" y="6035040"/>
+            <a:ext cx="7315200" cy="457200"/>
           </a:xfrm>
           <a:prstGeom prst="rect">
             <a:avLst/>
@@ -4314,8 +4314,8 @@
         </p:nvSpPr>
         <p:spPr>
           <a:xfrm>
-            <a:off x="5029200" y="3291840"/>
-            <a:ext cx="3657600" cy="457200"/>
+            <a:off x="10058400" y="6583680"/>
+            <a:ext cx="7315200" cy="914400"/>
           </a:xfrm>
           <a:prstGeom prst="rect">
             <a:avLst/>
@@ -4350,8 +4350,8 @@
         </p:nvSpPr>
         <p:spPr>
           <a:xfrm>
-            <a:off x="5029200" y="3794760"/>
-            <a:ext cx="3657600" cy="182880"/>
+            <a:off x="10058400" y="7589520"/>
+            <a:ext cx="7315200" cy="365760"/>
           </a:xfrm>
           <a:prstGeom prst="rect">
             <a:avLst/>
@@ -4386,8 +4386,8 @@
         </p:nvSpPr>
         <p:spPr>
           <a:xfrm>
-            <a:off x="640080" y="3017520"/>
-            <a:ext cx="3657600" cy="731520"/>
+            <a:off x="1280160" y="6035040"/>
+            <a:ext cx="7315200" cy="1463040"/>
           </a:xfrm>
           <a:prstGeom prst="rect">
             <a:avLst/>
@@ -4483,7 +4483,7 @@
         <p:spPr>
           <a:xfrm>
             <a:off x="0" y="0"/>
-            <a:ext cx="9144000" cy="731520"/>
+            <a:ext cx="18288000" cy="1463040"/>
           </a:xfrm>
           <a:prstGeom prst="rect">
             <a:avLst/>
@@ -4502,8 +4502,8 @@
         </p:nvSpPr>
         <p:spPr>
           <a:xfrm>
-            <a:off x="457200" y="182880"/>
-            <a:ext cx="8229600" cy="365760"/>
+            <a:off x="914400" y="365760"/>
+            <a:ext cx="16459200" cy="731520"/>
           </a:xfrm>
           <a:prstGeom prst="rect">
             <a:avLst/>
@@ -4538,8 +4538,8 @@
         </p:nvSpPr>
         <p:spPr>
           <a:xfrm>
-            <a:off x="640080" y="914400"/>
-            <a:ext cx="7863840" cy="274320"/>
+            <a:off x="1280160" y="1828800"/>
+            <a:ext cx="15727680" cy="548640"/>
           </a:xfrm>
           <a:prstGeom prst="rect">
             <a:avLst/>
@@ -4574,8 +4574,8 @@
         </p:nvSpPr>
         <p:spPr>
           <a:xfrm>
-            <a:off x="640080" y="1234440"/>
-            <a:ext cx="7863840" cy="365760"/>
+            <a:off x="1280160" y="2468880"/>
+            <a:ext cx="15727680" cy="731520"/>
           </a:xfrm>
           <a:prstGeom prst="rect">
             <a:avLst/>
@@ -4610,8 +4610,8 @@
         </p:nvSpPr>
         <p:spPr>
           <a:xfrm>
-            <a:off x="640080" y="1737360"/>
-            <a:ext cx="7863840" cy="228600"/>
+            <a:off x="1280160" y="3474720"/>
+            <a:ext cx="15727680" cy="457200"/>
           </a:xfrm>
           <a:prstGeom prst="rect">
             <a:avLst/>
@@ -4646,8 +4646,8 @@
         </p:nvSpPr>
         <p:spPr>
           <a:xfrm>
-            <a:off x="914400" y="2057400"/>
-            <a:ext cx="2286000" cy="274320"/>
+            <a:off x="1828800" y="4114800"/>
+            <a:ext cx="4572000" cy="548640"/>
           </a:xfrm>
           <a:prstGeom prst="rect">
             <a:avLst/>
@@ -4682,8 +4682,8 @@
         </p:nvSpPr>
         <p:spPr>
           <a:xfrm>
-            <a:off x="3474720" y="2057400"/>
-            <a:ext cx="2286000" cy="274320"/>
+            <a:off x="4389120" y="4114800"/>
+            <a:ext cx="4572000" cy="548640"/>
           </a:xfrm>
           <a:prstGeom prst="rect">
             <a:avLst/>
@@ -4718,8 +4718,8 @@
         </p:nvSpPr>
         <p:spPr>
           <a:xfrm>
-            <a:off x="6035040" y="2057400"/>
-            <a:ext cx="2286000" cy="274320"/>
+            <a:off x="6949440" y="4114800"/>
+            <a:ext cx="4572000" cy="548640"/>
           </a:xfrm>
           <a:prstGeom prst="rect">
             <a:avLst/>
@@ -4754,8 +4754,8 @@
         </p:nvSpPr>
         <p:spPr>
           <a:xfrm>
-            <a:off x="914400" y="2423160"/>
-            <a:ext cx="2286000" cy="274320"/>
+            <a:off x="1828800" y="4480560"/>
+            <a:ext cx="4572000" cy="548640"/>
           </a:xfrm>
           <a:prstGeom prst="rect">
             <a:avLst/>
@@ -4790,8 +4790,8 @@
         </p:nvSpPr>
         <p:spPr>
           <a:xfrm>
-            <a:off x="3474720" y="2423160"/>
-            <a:ext cx="2286000" cy="274320"/>
+            <a:off x="4389120" y="4480560"/>
+            <a:ext cx="4572000" cy="548640"/>
           </a:xfrm>
           <a:prstGeom prst="rect">
             <a:avLst/>
@@ -4826,8 +4826,8 @@
         </p:nvSpPr>
         <p:spPr>
           <a:xfrm>
-            <a:off x="640080" y="2926080"/>
-            <a:ext cx="7863840" cy="640080"/>
+            <a:off x="1280160" y="5852160"/>
+            <a:ext cx="15727680" cy="1280160"/>
           </a:xfrm>
           <a:prstGeom prst="rect">
             <a:avLst/>
@@ -4835,7 +4835,7 @@
           <a:solidFill>
             <a:srgbClr val="FFF3CD"/>
           </a:solidFill>
-          <a:ln w="25400">
+          <a:ln w="50800">
             <a:solidFill>
               <a:srgbClr val="FFC107"/>
             </a:solidFill>
@@ -4851,8 +4851,8 @@
         </p:nvSpPr>
         <p:spPr>
           <a:xfrm>
-            <a:off x="822960" y="3017520"/>
-            <a:ext cx="7498080" cy="457200"/>
+            <a:off x="1645920" y="6035040"/>
+            <a:ext cx="14996160" cy="914400"/>
           </a:xfrm>
           <a:prstGeom prst="rect">
             <a:avLst/>
@@ -4915,8 +4915,8 @@
         </p:nvSpPr>
         <p:spPr>
           <a:xfrm>
-            <a:off x="2286000" y="3749040"/>
-            <a:ext cx="4572000" cy="457200"/>
+            <a:off x="4572000" y="7498080"/>
+            <a:ext cx="9144000" cy="914400"/>
           </a:xfrm>
           <a:prstGeom prst="rect">
             <a:avLst/>
@@ -4935,8 +4935,8 @@
         </p:nvSpPr>
         <p:spPr>
           <a:xfrm>
-            <a:off x="2286000" y="3840480"/>
-            <a:ext cx="4572000" cy="274320"/>
+            <a:off x="4572000" y="7680960"/>
+            <a:ext cx="9144000" cy="548640"/>
           </a:xfrm>
           <a:prstGeom prst="rect">
             <a:avLst/>
@@ -5004,7 +5004,7 @@
         <p:spPr>
           <a:xfrm>
             <a:off x="0" y="0"/>
-            <a:ext cx="9144000" cy="731520"/>
+            <a:ext cx="18288000" cy="1463040"/>
           </a:xfrm>
           <a:prstGeom prst="rect">
             <a:avLst/>
@@ -5023,8 +5023,8 @@
         </p:nvSpPr>
         <p:spPr>
           <a:xfrm>
-            <a:off x="457200" y="182880"/>
-            <a:ext cx="8229600" cy="365760"/>
+            <a:off x="914400" y="365760"/>
+            <a:ext cx="16459200" cy="731520"/>
           </a:xfrm>
           <a:prstGeom prst="rect">
             <a:avLst/>
@@ -5059,8 +5059,8 @@
         </p:nvSpPr>
         <p:spPr>
           <a:xfrm>
-            <a:off x="640080" y="1005840"/>
-            <a:ext cx="274320" cy="274320"/>
+            <a:off x="1280160" y="2011680"/>
+            <a:ext cx="548640" cy="548640"/>
           </a:xfrm>
           <a:prstGeom prst="ellipse">
             <a:avLst/>
@@ -5068,7 +5068,7 @@
           <a:solidFill>
             <a:srgbClr val="D4AF37"/>
           </a:solidFill>
-          <a:ln w="25400">
+          <a:ln w="50800">
             <a:solidFill>
               <a:srgbClr val="FFFFFF"/>
             </a:solidFill>
@@ -5084,8 +5084,8 @@
         </p:nvSpPr>
         <p:spPr>
           <a:xfrm>
-            <a:off x="1097280" y="960120"/>
-            <a:ext cx="7589520" cy="640080"/>
+            <a:off x="2194560" y="1965960"/>
+            <a:ext cx="15179040" cy="1280160"/>
           </a:xfrm>
           <a:prstGeom prst="rect">
             <a:avLst/>
@@ -5093,7 +5093,7 @@
           <a:solidFill>
             <a:srgbClr val="FFFFFF"/>
           </a:solidFill>
-          <a:ln w="25400">
+          <a:ln w="50800">
             <a:solidFill>
               <a:srgbClr val="003366"/>
             </a:solidFill>
@@ -5109,8 +5109,8 @@
         </p:nvSpPr>
         <p:spPr>
           <a:xfrm>
-            <a:off x="1280160" y="1005840"/>
-            <a:ext cx="1828800" cy="182880"/>
+            <a:off x="2560320" y="2011680"/>
+            <a:ext cx="3657600" cy="365760"/>
           </a:xfrm>
           <a:prstGeom prst="rect">
             <a:avLst/>
@@ -5145,8 +5145,8 @@
         </p:nvSpPr>
         <p:spPr>
           <a:xfrm>
-            <a:off x="1280160" y="1207008"/>
-            <a:ext cx="7223760" cy="182880"/>
+            <a:off x="2560320" y="2212848"/>
+            <a:ext cx="14447520" cy="365760"/>
           </a:xfrm>
           <a:prstGeom prst="rect">
             <a:avLst/>
@@ -5181,8 +5181,8 @@
         </p:nvSpPr>
         <p:spPr>
           <a:xfrm>
-            <a:off x="1280160" y="1408176"/>
-            <a:ext cx="7223760" cy="137160"/>
+            <a:off x="2560320" y="2414016"/>
+            <a:ext cx="14447520" cy="274320"/>
           </a:xfrm>
           <a:prstGeom prst="rect">
             <a:avLst/>
@@ -5217,8 +5217,8 @@
         </p:nvSpPr>
         <p:spPr>
           <a:xfrm>
-            <a:off x="640080" y="1828800"/>
-            <a:ext cx="274320" cy="274320"/>
+            <a:off x="1280160" y="3657600"/>
+            <a:ext cx="548640" cy="548640"/>
           </a:xfrm>
           <a:prstGeom prst="ellipse">
             <a:avLst/>
@@ -5226,7 +5226,7 @@
           <a:solidFill>
             <a:srgbClr val="D4AF37"/>
           </a:solidFill>
-          <a:ln w="25400">
+          <a:ln w="50800">
             <a:solidFill>
               <a:srgbClr val="FFFFFF"/>
             </a:solidFill>
@@ -5242,8 +5242,8 @@
         </p:nvSpPr>
         <p:spPr>
           <a:xfrm>
-            <a:off x="1097280" y="1783080"/>
-            <a:ext cx="7589520" cy="640080"/>
+            <a:off x="2194560" y="3611880"/>
+            <a:ext cx="15179040" cy="1280160"/>
           </a:xfrm>
           <a:prstGeom prst="rect">
             <a:avLst/>
@@ -5251,7 +5251,7 @@
           <a:solidFill>
             <a:srgbClr val="FFFFFF"/>
           </a:solidFill>
-          <a:ln w="25400">
+          <a:ln w="50800">
             <a:solidFill>
               <a:srgbClr val="003366"/>
             </a:solidFill>
@@ -5267,8 +5267,8 @@
         </p:nvSpPr>
         <p:spPr>
           <a:xfrm>
-            <a:off x="1280160" y="1828800"/>
-            <a:ext cx="1828800" cy="182880"/>
+            <a:off x="2560320" y="3657600"/>
+            <a:ext cx="3657600" cy="365760"/>
           </a:xfrm>
           <a:prstGeom prst="rect">
             <a:avLst/>
@@ -5303,8 +5303,8 @@
         </p:nvSpPr>
         <p:spPr>
           <a:xfrm>
-            <a:off x="1280160" y="2029968"/>
-            <a:ext cx="7223760" cy="182880"/>
+            <a:off x="2560320" y="3858768"/>
+            <a:ext cx="14447520" cy="365760"/>
           </a:xfrm>
           <a:prstGeom prst="rect">
             <a:avLst/>
@@ -5339,8 +5339,8 @@
         </p:nvSpPr>
         <p:spPr>
           <a:xfrm>
-            <a:off x="1280160" y="2231136"/>
-            <a:ext cx="7223760" cy="137160"/>
+            <a:off x="2560320" y="4059936"/>
+            <a:ext cx="14447520" cy="274320"/>
           </a:xfrm>
           <a:prstGeom prst="rect">
             <a:avLst/>
@@ -5375,8 +5375,8 @@
         </p:nvSpPr>
         <p:spPr>
           <a:xfrm>
-            <a:off x="640080" y="2651760"/>
-            <a:ext cx="274320" cy="274320"/>
+            <a:off x="1280160" y="5303520"/>
+            <a:ext cx="548640" cy="548640"/>
           </a:xfrm>
           <a:prstGeom prst="ellipse">
             <a:avLst/>
@@ -5384,7 +5384,7 @@
           <a:solidFill>
             <a:srgbClr val="D4AF37"/>
           </a:solidFill>
-          <a:ln w="25400">
+          <a:ln w="50800">
             <a:solidFill>
               <a:srgbClr val="FFFFFF"/>
             </a:solidFill>
@@ -5400,8 +5400,8 @@
         </p:nvSpPr>
         <p:spPr>
           <a:xfrm>
-            <a:off x="1097280" y="2606040"/>
-            <a:ext cx="7589520" cy="640080"/>
+            <a:off x="2194560" y="5257800"/>
+            <a:ext cx="15179040" cy="1280160"/>
           </a:xfrm>
           <a:prstGeom prst="rect">
             <a:avLst/>
@@ -5409,7 +5409,7 @@
           <a:solidFill>
             <a:srgbClr val="FFFFFF"/>
           </a:solidFill>
-          <a:ln w="25400">
+          <a:ln w="50800">
             <a:solidFill>
               <a:srgbClr val="003366"/>
             </a:solidFill>
@@ -5425,8 +5425,8 @@
         </p:nvSpPr>
         <p:spPr>
           <a:xfrm>
-            <a:off x="1280160" y="2651760"/>
-            <a:ext cx="1828800" cy="182880"/>
+            <a:off x="2560320" y="5303520"/>
+            <a:ext cx="3657600" cy="365760"/>
           </a:xfrm>
           <a:prstGeom prst="rect">
             <a:avLst/>
@@ -5461,8 +5461,8 @@
         </p:nvSpPr>
         <p:spPr>
           <a:xfrm>
-            <a:off x="1280160" y="2852928"/>
-            <a:ext cx="7223760" cy="182880"/>
+            <a:off x="2560320" y="5504688"/>
+            <a:ext cx="14447520" cy="365760"/>
           </a:xfrm>
           <a:prstGeom prst="rect">
             <a:avLst/>
@@ -5497,8 +5497,8 @@
         </p:nvSpPr>
         <p:spPr>
           <a:xfrm>
-            <a:off x="1280160" y="3054096"/>
-            <a:ext cx="7223760" cy="137160"/>
+            <a:off x="2560320" y="5705856"/>
+            <a:ext cx="14447520" cy="274320"/>
           </a:xfrm>
           <a:prstGeom prst="rect">
             <a:avLst/>
@@ -5533,8 +5533,8 @@
         </p:nvSpPr>
         <p:spPr>
           <a:xfrm>
-            <a:off x="640080" y="3474720"/>
-            <a:ext cx="274320" cy="274320"/>
+            <a:off x="1280160" y="6949440"/>
+            <a:ext cx="548640" cy="548640"/>
           </a:xfrm>
           <a:prstGeom prst="ellipse">
             <a:avLst/>
@@ -5542,7 +5542,7 @@
           <a:solidFill>
             <a:srgbClr val="D4AF37"/>
           </a:solidFill>
-          <a:ln w="25400">
+          <a:ln w="50800">
             <a:solidFill>
               <a:srgbClr val="FFFFFF"/>
             </a:solidFill>
@@ -5558,8 +5558,8 @@
         </p:nvSpPr>
         <p:spPr>
           <a:xfrm>
-            <a:off x="1097280" y="3429000"/>
-            <a:ext cx="7589520" cy="640080"/>
+            <a:off x="2194560" y="6903720"/>
+            <a:ext cx="15179040" cy="1280160"/>
           </a:xfrm>
           <a:prstGeom prst="rect">
             <a:avLst/>
@@ -5567,7 +5567,7 @@
           <a:solidFill>
             <a:srgbClr val="FFFFFF"/>
           </a:solidFill>
-          <a:ln w="25400">
+          <a:ln w="50800">
             <a:solidFill>
               <a:srgbClr val="003366"/>
             </a:solidFill>
@@ -5583,8 +5583,8 @@
         </p:nvSpPr>
         <p:spPr>
           <a:xfrm>
-            <a:off x="1280160" y="3474720"/>
-            <a:ext cx="1828800" cy="182880"/>
+            <a:off x="2560320" y="6949440"/>
+            <a:ext cx="3657600" cy="365760"/>
           </a:xfrm>
           <a:prstGeom prst="rect">
             <a:avLst/>
@@ -5619,8 +5619,8 @@
         </p:nvSpPr>
         <p:spPr>
           <a:xfrm>
-            <a:off x="1280160" y="3675888"/>
-            <a:ext cx="7223760" cy="182880"/>
+            <a:off x="2560320" y="7150608"/>
+            <a:ext cx="14447520" cy="365760"/>
           </a:xfrm>
           <a:prstGeom prst="rect">
             <a:avLst/>
@@ -5655,8 +5655,8 @@
         </p:nvSpPr>
         <p:spPr>
           <a:xfrm>
-            <a:off x="1280160" y="3877056"/>
-            <a:ext cx="7223760" cy="137160"/>
+            <a:off x="2560320" y="7351776"/>
+            <a:ext cx="14447520" cy="274320"/>
           </a:xfrm>
           <a:prstGeom prst="rect">
             <a:avLst/>
@@ -5691,8 +5691,8 @@
         </p:nvSpPr>
         <p:spPr>
           <a:xfrm>
-            <a:off x="1371600" y="4297680"/>
-            <a:ext cx="6400800" cy="274320"/>
+            <a:off x="2743200" y="8595360"/>
+            <a:ext cx="12801600" cy="548640"/>
           </a:xfrm>
           <a:prstGeom prst="rect">
             <a:avLst/>
@@ -5711,8 +5711,8 @@
         </p:nvSpPr>
         <p:spPr>
           <a:xfrm>
-            <a:off x="1371600" y="4343400"/>
-            <a:ext cx="6400800" cy="182880"/>
+            <a:off x="2743200" y="8686800"/>
+            <a:ext cx="12801600" cy="365760"/>
           </a:xfrm>
           <a:prstGeom prst="rect">
             <a:avLst/>
@@ -5780,7 +5780,7 @@
         <p:spPr>
           <a:xfrm>
             <a:off x="0" y="0"/>
-            <a:ext cx="9144000" cy="731520"/>
+            <a:ext cx="18288000" cy="1463040"/>
           </a:xfrm>
           <a:prstGeom prst="rect">
             <a:avLst/>
@@ -5799,8 +5799,8 @@
         </p:nvSpPr>
         <p:spPr>
           <a:xfrm>
-            <a:off x="457200" y="182880"/>
-            <a:ext cx="8229600" cy="365760"/>
+            <a:off x="914400" y="365760"/>
+            <a:ext cx="16459200" cy="731520"/>
           </a:xfrm>
           <a:prstGeom prst="rect">
             <a:avLst/>
@@ -5836,7 +5836,7 @@
         <p:spPr>
           <a:xfrm>
             <a:off x="457200" y="914400"/>
-            <a:ext cx="4114800" cy="548640"/>
+            <a:ext cx="8229600" cy="1097280"/>
           </a:xfrm>
           <a:prstGeom prst="rect">
             <a:avLst/>
@@ -5844,7 +5844,7 @@
           <a:solidFill>
             <a:srgbClr val="FFFFFF"/>
           </a:solidFill>
-          <a:ln w="25400">
+          <a:ln w="50800">
             <a:solidFill>
               <a:srgbClr val="D4AF37"/>
             </a:solidFill>
@@ -5861,7 +5861,7 @@
         <p:spPr>
           <a:xfrm>
             <a:off x="640080" y="987552"/>
-            <a:ext cx="3749040" cy="201168"/>
+            <a:ext cx="7498080" cy="402336"/>
           </a:xfrm>
           <a:prstGeom prst="rect">
             <a:avLst/>
@@ -5897,7 +5897,7 @@
         <p:spPr>
           <a:xfrm>
             <a:off x="640080" y="1207008"/>
-            <a:ext cx="3749040" cy="182880"/>
+            <a:ext cx="7498080" cy="365760"/>
           </a:xfrm>
           <a:prstGeom prst="rect">
             <a:avLst/>
@@ -5933,7 +5933,7 @@
         <p:spPr>
           <a:xfrm>
             <a:off x="4572000" y="914400"/>
-            <a:ext cx="4114800" cy="548640"/>
+            <a:ext cx="8229600" cy="1097280"/>
           </a:xfrm>
           <a:prstGeom prst="rect">
             <a:avLst/>
@@ -5941,7 +5941,7 @@
           <a:solidFill>
             <a:srgbClr val="FFFFFF"/>
           </a:solidFill>
-          <a:ln w="25400">
+          <a:ln w="50800">
             <a:solidFill>
               <a:srgbClr val="D4AF37"/>
             </a:solidFill>
@@ -5958,7 +5958,7 @@
         <p:spPr>
           <a:xfrm>
             <a:off x="4754880" y="987552"/>
-            <a:ext cx="3749040" cy="201168"/>
+            <a:ext cx="7498080" cy="402336"/>
           </a:xfrm>
           <a:prstGeom prst="rect">
             <a:avLst/>
@@ -5994,7 +5994,7 @@
         <p:spPr>
           <a:xfrm>
             <a:off x="4754880" y="1207008"/>
-            <a:ext cx="3749040" cy="182880"/>
+            <a:ext cx="7498080" cy="365760"/>
           </a:xfrm>
           <a:prstGeom prst="rect">
             <a:avLst/>
@@ -6030,7 +6030,7 @@
         <p:spPr>
           <a:xfrm>
             <a:off x="457200" y="1554480"/>
-            <a:ext cx="4114800" cy="548640"/>
+            <a:ext cx="8229600" cy="1097280"/>
           </a:xfrm>
           <a:prstGeom prst="rect">
             <a:avLst/>
@@ -6038,7 +6038,7 @@
           <a:solidFill>
             <a:srgbClr val="FFFFFF"/>
           </a:solidFill>
-          <a:ln w="25400">
+          <a:ln w="50800">
             <a:solidFill>
               <a:srgbClr val="D4AF37"/>
             </a:solidFill>
@@ -6055,7 +6055,7 @@
         <p:spPr>
           <a:xfrm>
             <a:off x="640080" y="1627632"/>
-            <a:ext cx="3749040" cy="201168"/>
+            <a:ext cx="7498080" cy="402336"/>
           </a:xfrm>
           <a:prstGeom prst="rect">
             <a:avLst/>
@@ -6091,7 +6091,7 @@
         <p:spPr>
           <a:xfrm>
             <a:off x="640080" y="1847088"/>
-            <a:ext cx="3749040" cy="182880"/>
+            <a:ext cx="7498080" cy="365760"/>
           </a:xfrm>
           <a:prstGeom prst="rect">
             <a:avLst/>
@@ -6127,7 +6127,7 @@
         <p:spPr>
           <a:xfrm>
             <a:off x="4572000" y="1554480"/>
-            <a:ext cx="4114800" cy="548640"/>
+            <a:ext cx="8229600" cy="1097280"/>
           </a:xfrm>
           <a:prstGeom prst="rect">
             <a:avLst/>
@@ -6135,7 +6135,7 @@
           <a:solidFill>
             <a:srgbClr val="FFFFFF"/>
           </a:solidFill>
-          <a:ln w="25400">
+          <a:ln w="50800">
             <a:solidFill>
               <a:srgbClr val="D4AF37"/>
             </a:solidFill>
@@ -6152,7 +6152,7 @@
         <p:spPr>
           <a:xfrm>
             <a:off x="4754880" y="1627632"/>
-            <a:ext cx="3749040" cy="201168"/>
+            <a:ext cx="7498080" cy="402336"/>
           </a:xfrm>
           <a:prstGeom prst="rect">
             <a:avLst/>
@@ -6188,7 +6188,7 @@
         <p:spPr>
           <a:xfrm>
             <a:off x="4754880" y="1847088"/>
-            <a:ext cx="3749040" cy="182880"/>
+            <a:ext cx="7498080" cy="365760"/>
           </a:xfrm>
           <a:prstGeom prst="rect">
             <a:avLst/>
@@ -6224,7 +6224,7 @@
         <p:spPr>
           <a:xfrm>
             <a:off x="457200" y="2194560"/>
-            <a:ext cx="4114800" cy="548640"/>
+            <a:ext cx="8229600" cy="1097280"/>
           </a:xfrm>
           <a:prstGeom prst="rect">
             <a:avLst/>
@@ -6232,7 +6232,7 @@
           <a:solidFill>
             <a:srgbClr val="FFFFFF"/>
           </a:solidFill>
-          <a:ln w="25400">
+          <a:ln w="50800">
             <a:solidFill>
               <a:srgbClr val="D4AF37"/>
             </a:solidFill>
@@ -6249,7 +6249,7 @@
         <p:spPr>
           <a:xfrm>
             <a:off x="640080" y="2267712"/>
-            <a:ext cx="3749040" cy="201168"/>
+            <a:ext cx="7498080" cy="402336"/>
           </a:xfrm>
           <a:prstGeom prst="rect">
             <a:avLst/>
@@ -6285,7 +6285,7 @@
         <p:spPr>
           <a:xfrm>
             <a:off x="640080" y="2487168"/>
-            <a:ext cx="3749040" cy="182880"/>
+            <a:ext cx="7498080" cy="365760"/>
           </a:xfrm>
           <a:prstGeom prst="rect">
             <a:avLst/>
@@ -6321,7 +6321,7 @@
         <p:spPr>
           <a:xfrm>
             <a:off x="4572000" y="2194560"/>
-            <a:ext cx="4114800" cy="548640"/>
+            <a:ext cx="8229600" cy="1097280"/>
           </a:xfrm>
           <a:prstGeom prst="rect">
             <a:avLst/>
@@ -6329,7 +6329,7 @@
           <a:solidFill>
             <a:srgbClr val="FFFFFF"/>
           </a:solidFill>
-          <a:ln w="25400">
+          <a:ln w="50800">
             <a:solidFill>
               <a:srgbClr val="D4AF37"/>
             </a:solidFill>
@@ -6346,7 +6346,7 @@
         <p:spPr>
           <a:xfrm>
             <a:off x="4754880" y="2267712"/>
-            <a:ext cx="3749040" cy="201168"/>
+            <a:ext cx="7498080" cy="402336"/>
           </a:xfrm>
           <a:prstGeom prst="rect">
             <a:avLst/>
@@ -6382,7 +6382,7 @@
         <p:spPr>
           <a:xfrm>
             <a:off x="4754880" y="2487168"/>
-            <a:ext cx="3749040" cy="182880"/>
+            <a:ext cx="7498080" cy="365760"/>
           </a:xfrm>
           <a:prstGeom prst="rect">
             <a:avLst/>
@@ -6417,8 +6417,8 @@
         </p:nvSpPr>
         <p:spPr>
           <a:xfrm>
-            <a:off x="914400" y="3108960"/>
-            <a:ext cx="7315200" cy="822960"/>
+            <a:off x="1828800" y="6217920"/>
+            <a:ext cx="14630400" cy="1645920"/>
           </a:xfrm>
           <a:prstGeom prst="rect">
             <a:avLst/>
@@ -6426,7 +6426,7 @@
           <a:solidFill>
             <a:srgbClr val="003366"/>
           </a:solidFill>
-          <a:ln w="25400">
+          <a:ln w="50800">
             <a:solidFill>
               <a:srgbClr val="D4AF37"/>
             </a:solidFill>
@@ -6442,8 +6442,8 @@
         </p:nvSpPr>
         <p:spPr>
           <a:xfrm>
-            <a:off x="914400" y="3200400"/>
-            <a:ext cx="7315200" cy="228600"/>
+            <a:off x="1828800" y="6400800"/>
+            <a:ext cx="14630400" cy="457200"/>
           </a:xfrm>
           <a:prstGeom prst="rect">
             <a:avLst/>
@@ -6478,8 +6478,8 @@
         </p:nvSpPr>
         <p:spPr>
           <a:xfrm>
-            <a:off x="914400" y="3474720"/>
-            <a:ext cx="7315200" cy="365760"/>
+            <a:off x="1828800" y="6949440"/>
+            <a:ext cx="14630400" cy="731520"/>
           </a:xfrm>
           <a:prstGeom prst="rect">
             <a:avLst/>
@@ -6561,7 +6561,7 @@
         <p:spPr>
           <a:xfrm>
             <a:off x="0" y="0"/>
-            <a:ext cx="9144000" cy="731520"/>
+            <a:ext cx="18288000" cy="1463040"/>
           </a:xfrm>
           <a:prstGeom prst="rect">
             <a:avLst/>
@@ -6580,8 +6580,8 @@
         </p:nvSpPr>
         <p:spPr>
           <a:xfrm>
-            <a:off x="457200" y="182880"/>
-            <a:ext cx="8229600" cy="365760"/>
+            <a:off x="914400" y="365760"/>
+            <a:ext cx="16459200" cy="731520"/>
           </a:xfrm>
           <a:prstGeom prst="rect">
             <a:avLst/>
@@ -6616,8 +6616,8 @@
         </p:nvSpPr>
         <p:spPr>
           <a:xfrm>
-            <a:off x="548640" y="1005840"/>
-            <a:ext cx="365760" cy="365760"/>
+            <a:off x="1097280" y="2011680"/>
+            <a:ext cx="731520" cy="731520"/>
           </a:xfrm>
           <a:prstGeom prst="ellipse">
             <a:avLst/>
@@ -6636,8 +6636,8 @@
         </p:nvSpPr>
         <p:spPr>
           <a:xfrm>
-            <a:off x="548640" y="1005840"/>
-            <a:ext cx="365760" cy="365760"/>
+            <a:off x="1097280" y="2011680"/>
+            <a:ext cx="731520" cy="731520"/>
           </a:xfrm>
           <a:prstGeom prst="rect">
             <a:avLst/>
@@ -6672,8 +6672,8 @@
         </p:nvSpPr>
         <p:spPr>
           <a:xfrm>
-            <a:off x="1097280" y="1024128"/>
-            <a:ext cx="7315200" cy="182880"/>
+            <a:off x="2194560" y="2029968"/>
+            <a:ext cx="14630400" cy="365760"/>
           </a:xfrm>
           <a:prstGeom prst="rect">
             <a:avLst/>
@@ -6708,8 +6708,8 @@
         </p:nvSpPr>
         <p:spPr>
           <a:xfrm>
-            <a:off x="1097280" y="1225296"/>
-            <a:ext cx="7315200" cy="137160"/>
+            <a:off x="2194560" y="2231136"/>
+            <a:ext cx="14630400" cy="274320"/>
           </a:xfrm>
           <a:prstGeom prst="rect">
             <a:avLst/>
@@ -6744,8 +6744,8 @@
         </p:nvSpPr>
         <p:spPr>
           <a:xfrm>
-            <a:off x="548640" y="1645920"/>
-            <a:ext cx="365760" cy="365760"/>
+            <a:off x="1097280" y="3291840"/>
+            <a:ext cx="731520" cy="731520"/>
           </a:xfrm>
           <a:prstGeom prst="ellipse">
             <a:avLst/>
@@ -6764,8 +6764,8 @@
         </p:nvSpPr>
         <p:spPr>
           <a:xfrm>
-            <a:off x="548640" y="1645920"/>
-            <a:ext cx="365760" cy="365760"/>
+            <a:off x="1097280" y="3291840"/>
+            <a:ext cx="731520" cy="731520"/>
           </a:xfrm>
           <a:prstGeom prst="rect">
             <a:avLst/>
@@ -6800,8 +6800,8 @@
         </p:nvSpPr>
         <p:spPr>
           <a:xfrm>
-            <a:off x="1097280" y="1664208"/>
-            <a:ext cx="7315200" cy="182880"/>
+            <a:off x="2194560" y="3310128"/>
+            <a:ext cx="14630400" cy="365760"/>
           </a:xfrm>
           <a:prstGeom prst="rect">
             <a:avLst/>
@@ -6836,8 +6836,8 @@
         </p:nvSpPr>
         <p:spPr>
           <a:xfrm>
-            <a:off x="1097280" y="1865376"/>
-            <a:ext cx="7315200" cy="137160"/>
+            <a:off x="2194560" y="3511296"/>
+            <a:ext cx="14630400" cy="274320"/>
           </a:xfrm>
           <a:prstGeom prst="rect">
             <a:avLst/>
@@ -6872,8 +6872,8 @@
         </p:nvSpPr>
         <p:spPr>
           <a:xfrm>
-            <a:off x="548640" y="2286000"/>
-            <a:ext cx="365760" cy="365760"/>
+            <a:off x="1097280" y="4572000"/>
+            <a:ext cx="731520" cy="731520"/>
           </a:xfrm>
           <a:prstGeom prst="ellipse">
             <a:avLst/>
@@ -6892,8 +6892,8 @@
         </p:nvSpPr>
         <p:spPr>
           <a:xfrm>
-            <a:off x="548640" y="2286000"/>
-            <a:ext cx="365760" cy="365760"/>
+            <a:off x="1097280" y="4572000"/>
+            <a:ext cx="731520" cy="731520"/>
           </a:xfrm>
           <a:prstGeom prst="rect">
             <a:avLst/>
@@ -6928,8 +6928,8 @@
         </p:nvSpPr>
         <p:spPr>
           <a:xfrm>
-            <a:off x="1097280" y="2304288"/>
-            <a:ext cx="7315200" cy="182880"/>
+            <a:off x="2194560" y="4590288"/>
+            <a:ext cx="14630400" cy="365760"/>
           </a:xfrm>
           <a:prstGeom prst="rect">
             <a:avLst/>
@@ -6964,8 +6964,8 @@
         </p:nvSpPr>
         <p:spPr>
           <a:xfrm>
-            <a:off x="1097280" y="2505456"/>
-            <a:ext cx="7315200" cy="137160"/>
+            <a:off x="2194560" y="4791456"/>
+            <a:ext cx="14630400" cy="274320"/>
           </a:xfrm>
           <a:prstGeom prst="rect">
             <a:avLst/>
@@ -7000,8 +7000,8 @@
         </p:nvSpPr>
         <p:spPr>
           <a:xfrm>
-            <a:off x="548640" y="2926080"/>
-            <a:ext cx="365760" cy="365760"/>
+            <a:off x="1097280" y="5852160"/>
+            <a:ext cx="731520" cy="731520"/>
           </a:xfrm>
           <a:prstGeom prst="ellipse">
             <a:avLst/>
@@ -7020,8 +7020,8 @@
         </p:nvSpPr>
         <p:spPr>
           <a:xfrm>
-            <a:off x="548640" y="2926080"/>
-            <a:ext cx="365760" cy="365760"/>
+            <a:off x="1097280" y="5852160"/>
+            <a:ext cx="731520" cy="731520"/>
           </a:xfrm>
           <a:prstGeom prst="rect">
             <a:avLst/>
@@ -7056,8 +7056,8 @@
         </p:nvSpPr>
         <p:spPr>
           <a:xfrm>
-            <a:off x="1097280" y="2944368"/>
-            <a:ext cx="7315200" cy="182880"/>
+            <a:off x="2194560" y="5870448"/>
+            <a:ext cx="14630400" cy="365760"/>
           </a:xfrm>
           <a:prstGeom prst="rect">
             <a:avLst/>
@@ -7092,8 +7092,8 @@
         </p:nvSpPr>
         <p:spPr>
           <a:xfrm>
-            <a:off x="1097280" y="3145536"/>
-            <a:ext cx="7315200" cy="137160"/>
+            <a:off x="2194560" y="6071616"/>
+            <a:ext cx="14630400" cy="274320"/>
           </a:xfrm>
           <a:prstGeom prst="rect">
             <a:avLst/>
@@ -7128,8 +7128,8 @@
         </p:nvSpPr>
         <p:spPr>
           <a:xfrm>
-            <a:off x="548640" y="3566160"/>
-            <a:ext cx="365760" cy="365760"/>
+            <a:off x="1097280" y="7132320"/>
+            <a:ext cx="731520" cy="731520"/>
           </a:xfrm>
           <a:prstGeom prst="ellipse">
             <a:avLst/>
@@ -7148,8 +7148,8 @@
         </p:nvSpPr>
         <p:spPr>
           <a:xfrm>
-            <a:off x="548640" y="3566160"/>
-            <a:ext cx="365760" cy="365760"/>
+            <a:off x="1097280" y="7132320"/>
+            <a:ext cx="731520" cy="731520"/>
           </a:xfrm>
           <a:prstGeom prst="rect">
             <a:avLst/>
@@ -7184,8 +7184,8 @@
         </p:nvSpPr>
         <p:spPr>
           <a:xfrm>
-            <a:off x="1097280" y="3584448"/>
-            <a:ext cx="7315200" cy="182880"/>
+            <a:off x="2194560" y="7150608"/>
+            <a:ext cx="14630400" cy="365760"/>
           </a:xfrm>
           <a:prstGeom prst="rect">
             <a:avLst/>
@@ -7220,8 +7220,8 @@
         </p:nvSpPr>
         <p:spPr>
           <a:xfrm>
-            <a:off x="1097280" y="3785616"/>
-            <a:ext cx="7315200" cy="137160"/>
+            <a:off x="2194560" y="7351776"/>
+            <a:ext cx="14630400" cy="274320"/>
           </a:xfrm>
           <a:prstGeom prst="rect">
             <a:avLst/>
@@ -7288,8 +7288,8 @@
         </p:nvSpPr>
         <p:spPr>
           <a:xfrm>
-            <a:off x="914400" y="914400"/>
-            <a:ext cx="7315200" cy="731520"/>
+            <a:off x="1828800" y="1828800"/>
+            <a:ext cx="14630400" cy="1463040"/>
           </a:xfrm>
           <a:prstGeom prst="rect">
             <a:avLst/>
@@ -7324,8 +7324,8 @@
         </p:nvSpPr>
         <p:spPr>
           <a:xfrm>
-            <a:off x="3840480" y="960120"/>
-            <a:ext cx="1463040" cy="640080"/>
+            <a:off x="7680960" y="1920240"/>
+            <a:ext cx="2926080" cy="1280160"/>
           </a:xfrm>
           <a:prstGeom prst="rect">
             <a:avLst/>
@@ -7360,8 +7360,8 @@
         </p:nvSpPr>
         <p:spPr>
           <a:xfrm>
-            <a:off x="685800" y="2011680"/>
-            <a:ext cx="2560320" cy="731520"/>
+            <a:off x="1371600" y="4023360"/>
+            <a:ext cx="5120640" cy="1463040"/>
           </a:xfrm>
           <a:prstGeom prst="rect">
             <a:avLst/>
@@ -7369,7 +7369,7 @@
           <a:solidFill>
             <a:srgbClr val="FFFFFF"/>
           </a:solidFill>
-          <a:ln w="25400">
+          <a:ln w="50800">
             <a:solidFill>
               <a:srgbClr val="D4AF37"/>
             </a:solidFill>
@@ -7385,8 +7385,8 @@
         </p:nvSpPr>
         <p:spPr>
           <a:xfrm>
-            <a:off x="685800" y="2084832"/>
-            <a:ext cx="2560320" cy="182880"/>
+            <a:off x="1371600" y="4169664"/>
+            <a:ext cx="5120640" cy="365760"/>
           </a:xfrm>
           <a:prstGeom prst="rect">
             <a:avLst/>
@@ -7421,8 +7421,8 @@
         </p:nvSpPr>
         <p:spPr>
           <a:xfrm>
-            <a:off x="685800" y="2304288"/>
-            <a:ext cx="2560320" cy="365760"/>
+            <a:off x="1371600" y="4608576"/>
+            <a:ext cx="5120640" cy="731520"/>
           </a:xfrm>
           <a:prstGeom prst="rect">
             <a:avLst/>
@@ -7457,8 +7457,8 @@
         </p:nvSpPr>
         <p:spPr>
           <a:xfrm>
-            <a:off x="3200400" y="2011680"/>
-            <a:ext cx="2560320" cy="731520"/>
+            <a:off x="6400800" y="4023360"/>
+            <a:ext cx="5120640" cy="1463040"/>
           </a:xfrm>
           <a:prstGeom prst="rect">
             <a:avLst/>
@@ -7466,7 +7466,7 @@
           <a:solidFill>
             <a:srgbClr val="FFFFFF"/>
           </a:solidFill>
-          <a:ln w="25400">
+          <a:ln w="50800">
             <a:solidFill>
               <a:srgbClr val="D4AF37"/>
             </a:solidFill>
@@ -7482,8 +7482,8 @@
         </p:nvSpPr>
         <p:spPr>
           <a:xfrm>
-            <a:off x="3200400" y="2084832"/>
-            <a:ext cx="2560320" cy="182880"/>
+            <a:off x="6400800" y="4169664"/>
+            <a:ext cx="5120640" cy="365760"/>
           </a:xfrm>
           <a:prstGeom prst="rect">
             <a:avLst/>
@@ -7518,8 +7518,8 @@
         </p:nvSpPr>
         <p:spPr>
           <a:xfrm>
-            <a:off x="3200400" y="2304288"/>
-            <a:ext cx="2560320" cy="365760"/>
+            <a:off x="6400800" y="4608576"/>
+            <a:ext cx="5120640" cy="731520"/>
           </a:xfrm>
           <a:prstGeom prst="rect">
             <a:avLst/>
@@ -7554,8 +7554,8 @@
         </p:nvSpPr>
         <p:spPr>
           <a:xfrm>
-            <a:off x="5715000" y="2011680"/>
-            <a:ext cx="2560320" cy="731520"/>
+            <a:off x="11430000" y="4023360"/>
+            <a:ext cx="5120640" cy="1463040"/>
           </a:xfrm>
           <a:prstGeom prst="rect">
             <a:avLst/>
@@ -7563,7 +7563,7 @@
           <a:solidFill>
             <a:srgbClr val="FFFFFF"/>
           </a:solidFill>
-          <a:ln w="25400">
+          <a:ln w="50800">
             <a:solidFill>
               <a:srgbClr val="D4AF37"/>
             </a:solidFill>
@@ -7579,8 +7579,8 @@
         </p:nvSpPr>
         <p:spPr>
           <a:xfrm>
-            <a:off x="5715000" y="2084832"/>
-            <a:ext cx="2560320" cy="182880"/>
+            <a:off x="11430000" y="4169664"/>
+            <a:ext cx="5120640" cy="365760"/>
           </a:xfrm>
           <a:prstGeom prst="rect">
             <a:avLst/>
@@ -7615,8 +7615,8 @@
         </p:nvSpPr>
         <p:spPr>
           <a:xfrm>
-            <a:off x="5715000" y="2304288"/>
-            <a:ext cx="2560320" cy="365760"/>
+            <a:off x="11430000" y="4608576"/>
+            <a:ext cx="5120640" cy="731520"/>
           </a:xfrm>
           <a:prstGeom prst="rect">
             <a:avLst/>
@@ -7665,8 +7665,8 @@
         </p:nvSpPr>
         <p:spPr>
           <a:xfrm>
-            <a:off x="1371600" y="3017520"/>
-            <a:ext cx="6400800" cy="640080"/>
+            <a:off x="2743200" y="6035040"/>
+            <a:ext cx="12801600" cy="1280160"/>
           </a:xfrm>
           <a:prstGeom prst="rect">
             <a:avLst/>
@@ -7685,8 +7685,8 @@
         </p:nvSpPr>
         <p:spPr>
           <a:xfrm>
-            <a:off x="1371600" y="3063240"/>
-            <a:ext cx="6400800" cy="548640"/>
+            <a:off x="2743200" y="6126480"/>
+            <a:ext cx="12801600" cy="1097280"/>
           </a:xfrm>
           <a:prstGeom prst="rect">
             <a:avLst/>
@@ -7735,8 +7735,8 @@
         </p:nvSpPr>
         <p:spPr>
           <a:xfrm>
-            <a:off x="914400" y="3840480"/>
-            <a:ext cx="7315200" cy="365760"/>
+            <a:off x="1828800" y="7680960"/>
+            <a:ext cx="14630400" cy="731520"/>
           </a:xfrm>
           <a:prstGeom prst="rect">
             <a:avLst/>
@@ -7818,7 +7818,7 @@
         <p:spPr>
           <a:xfrm>
             <a:off x="0" y="0"/>
-            <a:ext cx="9144000" cy="731520"/>
+            <a:ext cx="18288000" cy="1463040"/>
           </a:xfrm>
           <a:prstGeom prst="rect">
             <a:avLst/>
@@ -7837,8 +7837,8 @@
         </p:nvSpPr>
         <p:spPr>
           <a:xfrm>
-            <a:off x="457200" y="182880"/>
-            <a:ext cx="8229600" cy="365760"/>
+            <a:off x="914400" y="365760"/>
+            <a:ext cx="16459200" cy="731520"/>
           </a:xfrm>
           <a:prstGeom prst="rect">
             <a:avLst/>
@@ -7873,8 +7873,8 @@
         </p:nvSpPr>
         <p:spPr>
           <a:xfrm>
-            <a:off x="457200" y="1097280"/>
-            <a:ext cx="3657600" cy="914400"/>
+            <a:off x="914400" y="2194560"/>
+            <a:ext cx="7315200" cy="1828800"/>
           </a:xfrm>
           <a:prstGeom prst="rect">
             <a:avLst/>
@@ -7882,7 +7882,7 @@
           <a:solidFill>
             <a:srgbClr val="FFFFFF"/>
           </a:solidFill>
-          <a:ln w="50800">
+          <a:ln w="101600">
             <a:solidFill>
               <a:srgbClr val="DC3545"/>
             </a:solidFill>
@@ -7898,8 +7898,8 @@
         </p:nvSpPr>
         <p:spPr>
           <a:xfrm>
-            <a:off x="640080" y="1188720"/>
-            <a:ext cx="3291840" cy="457200"/>
+            <a:off x="1280160" y="2377440"/>
+            <a:ext cx="6583680" cy="914400"/>
           </a:xfrm>
           <a:prstGeom prst="rect">
             <a:avLst/>
@@ -7934,8 +7934,8 @@
         </p:nvSpPr>
         <p:spPr>
           <a:xfrm>
-            <a:off x="640080" y="1645920"/>
-            <a:ext cx="3291840" cy="274320"/>
+            <a:off x="1280160" y="3291840"/>
+            <a:ext cx="6583680" cy="548640"/>
           </a:xfrm>
           <a:prstGeom prst="rect">
             <a:avLst/>
@@ -7970,8 +7970,8 @@
         </p:nvSpPr>
         <p:spPr>
           <a:xfrm>
-            <a:off x="457200" y="2194560"/>
-            <a:ext cx="3657600" cy="914400"/>
+            <a:off x="914400" y="4389120"/>
+            <a:ext cx="7315200" cy="1828800"/>
           </a:xfrm>
           <a:prstGeom prst="rect">
             <a:avLst/>
@@ -7979,7 +7979,7 @@
           <a:solidFill>
             <a:srgbClr val="FFFFFF"/>
           </a:solidFill>
-          <a:ln w="50800">
+          <a:ln w="101600">
             <a:solidFill>
               <a:srgbClr val="DC3545"/>
             </a:solidFill>
@@ -7995,8 +7995,8 @@
         </p:nvSpPr>
         <p:spPr>
           <a:xfrm>
-            <a:off x="640080" y="2286000"/>
-            <a:ext cx="3291840" cy="457200"/>
+            <a:off x="1280160" y="4572000"/>
+            <a:ext cx="6583680" cy="914400"/>
           </a:xfrm>
           <a:prstGeom prst="rect">
             <a:avLst/>
@@ -8031,8 +8031,8 @@
         </p:nvSpPr>
         <p:spPr>
           <a:xfrm>
-            <a:off x="640080" y="2743200"/>
-            <a:ext cx="3291840" cy="274320"/>
+            <a:off x="1280160" y="5486400"/>
+            <a:ext cx="6583680" cy="548640"/>
           </a:xfrm>
           <a:prstGeom prst="rect">
             <a:avLst/>
@@ -8081,8 +8081,8 @@
         </p:nvSpPr>
         <p:spPr>
           <a:xfrm>
-            <a:off x="4572000" y="1097280"/>
-            <a:ext cx="4114800" cy="731520"/>
+            <a:off x="9144000" y="2194560"/>
+            <a:ext cx="8229600" cy="1463040"/>
           </a:xfrm>
           <a:prstGeom prst="rect">
             <a:avLst/>
@@ -8090,7 +8090,7 @@
           <a:solidFill>
             <a:srgbClr val="FFFFFF"/>
           </a:solidFill>
-          <a:ln w="12700">
+          <a:ln w="25400">
             <a:solidFill>
               <a:srgbClr val="E0E0E0"/>
             </a:solidFill>
@@ -8106,8 +8106,8 @@
         </p:nvSpPr>
         <p:spPr>
           <a:xfrm>
-            <a:off x="4754880" y="1188720"/>
-            <a:ext cx="3749040" cy="274320"/>
+            <a:off x="9509760" y="2377440"/>
+            <a:ext cx="7498080" cy="548640"/>
           </a:xfrm>
           <a:prstGeom prst="rect">
             <a:avLst/>
@@ -8142,8 +8142,8 @@
         </p:nvSpPr>
         <p:spPr>
           <a:xfrm>
-            <a:off x="4754880" y="1463040"/>
-            <a:ext cx="3749040" cy="274320"/>
+            <a:off x="9509760" y="2926080"/>
+            <a:ext cx="7498080" cy="548640"/>
           </a:xfrm>
           <a:prstGeom prst="rect">
             <a:avLst/>
@@ -8178,8 +8178,8 @@
         </p:nvSpPr>
         <p:spPr>
           <a:xfrm>
-            <a:off x="4572000" y="2011680"/>
-            <a:ext cx="4114800" cy="731520"/>
+            <a:off x="9144000" y="4023360"/>
+            <a:ext cx="8229600" cy="1463040"/>
           </a:xfrm>
           <a:prstGeom prst="rect">
             <a:avLst/>
@@ -8187,7 +8187,7 @@
           <a:solidFill>
             <a:srgbClr val="FFFFFF"/>
           </a:solidFill>
-          <a:ln w="12700">
+          <a:ln w="25400">
             <a:solidFill>
               <a:srgbClr val="E0E0E0"/>
             </a:solidFill>
@@ -8203,8 +8203,8 @@
         </p:nvSpPr>
         <p:spPr>
           <a:xfrm>
-            <a:off x="4754880" y="2103120"/>
-            <a:ext cx="3749040" cy="274320"/>
+            <a:off x="9509760" y="4206240"/>
+            <a:ext cx="7498080" cy="548640"/>
           </a:xfrm>
           <a:prstGeom prst="rect">
             <a:avLst/>
@@ -8239,8 +8239,8 @@
         </p:nvSpPr>
         <p:spPr>
           <a:xfrm>
-            <a:off x="4754880" y="2377440"/>
-            <a:ext cx="3749040" cy="274320"/>
+            <a:off x="9509760" y="4754880"/>
+            <a:ext cx="7498080" cy="548640"/>
           </a:xfrm>
           <a:prstGeom prst="rect">
             <a:avLst/>
@@ -8275,8 +8275,8 @@
         </p:nvSpPr>
         <p:spPr>
           <a:xfrm>
-            <a:off x="457200" y="3474720"/>
-            <a:ext cx="8229600" cy="731520"/>
+            <a:off x="914400" y="6949440"/>
+            <a:ext cx="16459200" cy="1463040"/>
           </a:xfrm>
           <a:prstGeom prst="rect">
             <a:avLst/>
@@ -8295,8 +8295,8 @@
         </p:nvSpPr>
         <p:spPr>
           <a:xfrm>
-            <a:off x="457200" y="3566160"/>
-            <a:ext cx="8229600" cy="548640"/>
+            <a:off x="914400" y="7132320"/>
+            <a:ext cx="16459200" cy="1097280"/>
           </a:xfrm>
           <a:prstGeom prst="rect">
             <a:avLst/>
@@ -8364,7 +8364,7 @@
         <p:spPr>
           <a:xfrm>
             <a:off x="0" y="0"/>
-            <a:ext cx="9144000" cy="731520"/>
+            <a:ext cx="18288000" cy="1463040"/>
           </a:xfrm>
           <a:prstGeom prst="rect">
             <a:avLst/>
@@ -8383,8 +8383,8 @@
         </p:nvSpPr>
         <p:spPr>
           <a:xfrm>
-            <a:off x="457200" y="182880"/>
-            <a:ext cx="8229600" cy="365760"/>
+            <a:off x="914400" y="365760"/>
+            <a:ext cx="16459200" cy="731520"/>
           </a:xfrm>
           <a:prstGeom prst="rect">
             <a:avLst/>
@@ -8419,8 +8419,8 @@
         </p:nvSpPr>
         <p:spPr>
           <a:xfrm>
-            <a:off x="457200" y="1005840"/>
-            <a:ext cx="8229600" cy="640080"/>
+            <a:off x="914400" y="2011680"/>
+            <a:ext cx="16459200" cy="1280160"/>
           </a:xfrm>
           <a:prstGeom prst="rect">
             <a:avLst/>
@@ -8428,7 +8428,7 @@
           <a:solidFill>
             <a:srgbClr val="FFFFFF"/>
           </a:solidFill>
-          <a:ln w="38100">
+          <a:ln w="76200">
             <a:solidFill>
               <a:srgbClr val="DC3545"/>
             </a:solidFill>
@@ -8444,8 +8444,8 @@
         </p:nvSpPr>
         <p:spPr>
           <a:xfrm>
-            <a:off x="640080" y="1051560"/>
-            <a:ext cx="7863840" cy="228600"/>
+            <a:off x="1280160" y="2057400"/>
+            <a:ext cx="15727680" cy="457200"/>
           </a:xfrm>
           <a:prstGeom prst="rect">
             <a:avLst/>
@@ -8480,8 +8480,8 @@
         </p:nvSpPr>
         <p:spPr>
           <a:xfrm>
-            <a:off x="640080" y="1298448"/>
-            <a:ext cx="7863840" cy="320040"/>
+            <a:off x="1280160" y="2304288"/>
+            <a:ext cx="15727680" cy="640080"/>
           </a:xfrm>
           <a:prstGeom prst="rect">
             <a:avLst/>
@@ -8516,8 +8516,8 @@
         </p:nvSpPr>
         <p:spPr>
           <a:xfrm>
-            <a:off x="457200" y="1737360"/>
-            <a:ext cx="8229600" cy="640080"/>
+            <a:off x="914400" y="3474720"/>
+            <a:ext cx="16459200" cy="1280160"/>
           </a:xfrm>
           <a:prstGeom prst="rect">
             <a:avLst/>
@@ -8525,7 +8525,7 @@
           <a:solidFill>
             <a:srgbClr val="FFFFFF"/>
           </a:solidFill>
-          <a:ln w="38100">
+          <a:ln w="76200">
             <a:solidFill>
               <a:srgbClr val="DC3545"/>
             </a:solidFill>
@@ -8541,8 +8541,8 @@
         </p:nvSpPr>
         <p:spPr>
           <a:xfrm>
-            <a:off x="640080" y="1783080"/>
-            <a:ext cx="7863840" cy="228600"/>
+            <a:off x="1280160" y="3520440"/>
+            <a:ext cx="15727680" cy="457200"/>
           </a:xfrm>
           <a:prstGeom prst="rect">
             <a:avLst/>
@@ -8577,8 +8577,8 @@
         </p:nvSpPr>
         <p:spPr>
           <a:xfrm>
-            <a:off x="640080" y="2029968"/>
-            <a:ext cx="7863840" cy="320040"/>
+            <a:off x="1280160" y="3767328"/>
+            <a:ext cx="15727680" cy="640080"/>
           </a:xfrm>
           <a:prstGeom prst="rect">
             <a:avLst/>
@@ -8613,8 +8613,8 @@
         </p:nvSpPr>
         <p:spPr>
           <a:xfrm>
-            <a:off x="457200" y="2468880"/>
-            <a:ext cx="8229600" cy="640080"/>
+            <a:off x="914400" y="4937760"/>
+            <a:ext cx="16459200" cy="1280160"/>
           </a:xfrm>
           <a:prstGeom prst="rect">
             <a:avLst/>
@@ -8622,7 +8622,7 @@
           <a:solidFill>
             <a:srgbClr val="FFFFFF"/>
           </a:solidFill>
-          <a:ln w="38100">
+          <a:ln w="76200">
             <a:solidFill>
               <a:srgbClr val="DC3545"/>
             </a:solidFill>
@@ -8638,8 +8638,8 @@
         </p:nvSpPr>
         <p:spPr>
           <a:xfrm>
-            <a:off x="640080" y="2514600"/>
-            <a:ext cx="7863840" cy="228600"/>
+            <a:off x="1280160" y="4983480"/>
+            <a:ext cx="15727680" cy="457200"/>
           </a:xfrm>
           <a:prstGeom prst="rect">
             <a:avLst/>
@@ -8674,8 +8674,8 @@
         </p:nvSpPr>
         <p:spPr>
           <a:xfrm>
-            <a:off x="640080" y="2761488"/>
-            <a:ext cx="7863840" cy="320040"/>
+            <a:off x="1280160" y="5230368"/>
+            <a:ext cx="15727680" cy="640080"/>
           </a:xfrm>
           <a:prstGeom prst="rect">
             <a:avLst/>
@@ -8710,8 +8710,8 @@
         </p:nvSpPr>
         <p:spPr>
           <a:xfrm>
-            <a:off x="457200" y="3383280"/>
-            <a:ext cx="8229600" cy="822960"/>
+            <a:off x="914400" y="6766560"/>
+            <a:ext cx="16459200" cy="1645920"/>
           </a:xfrm>
           <a:prstGeom prst="rect">
             <a:avLst/>
@@ -8719,7 +8719,7 @@
           <a:solidFill>
             <a:srgbClr val="F8F9FA"/>
           </a:solidFill>
-          <a:ln w="38100">
+          <a:ln w="76200">
             <a:solidFill>
               <a:srgbClr val="7FCDCD"/>
             </a:solidFill>
@@ -8735,8 +8735,8 @@
         </p:nvSpPr>
         <p:spPr>
           <a:xfrm>
-            <a:off x="640080" y="3474720"/>
-            <a:ext cx="7863840" cy="457200"/>
+            <a:off x="1280160" y="6949440"/>
+            <a:ext cx="15727680" cy="914400"/>
           </a:xfrm>
           <a:prstGeom prst="rect">
             <a:avLst/>
@@ -8771,8 +8771,8 @@
         </p:nvSpPr>
         <p:spPr>
           <a:xfrm>
-            <a:off x="640080" y="3977640"/>
-            <a:ext cx="7863840" cy="182880"/>
+            <a:off x="1280160" y="7955280"/>
+            <a:ext cx="15727680" cy="365760"/>
           </a:xfrm>
           <a:prstGeom prst="rect">
             <a:avLst/>
@@ -8840,7 +8840,7 @@
         <p:spPr>
           <a:xfrm>
             <a:off x="0" y="0"/>
-            <a:ext cx="9144000" cy="731520"/>
+            <a:ext cx="18288000" cy="1463040"/>
           </a:xfrm>
           <a:prstGeom prst="rect">
             <a:avLst/>
@@ -8859,8 +8859,8 @@
         </p:nvSpPr>
         <p:spPr>
           <a:xfrm>
-            <a:off x="457200" y="182880"/>
-            <a:ext cx="8229600" cy="365760"/>
+            <a:off x="914400" y="365760"/>
+            <a:ext cx="16459200" cy="731520"/>
           </a:xfrm>
           <a:prstGeom prst="rect">
             <a:avLst/>
@@ -8895,8 +8895,8 @@
         </p:nvSpPr>
         <p:spPr>
           <a:xfrm>
-            <a:off x="457200" y="914400"/>
-            <a:ext cx="4114800" cy="1005840"/>
+            <a:off x="914400" y="1828800"/>
+            <a:ext cx="8229600" cy="2011680"/>
           </a:xfrm>
           <a:prstGeom prst="rect">
             <a:avLst/>
@@ -8904,7 +8904,7 @@
           <a:solidFill>
             <a:srgbClr val="FFFFFF"/>
           </a:solidFill>
-          <a:ln w="12700">
+          <a:ln w="25400">
             <a:solidFill>
               <a:srgbClr val="E0E0E0"/>
             </a:solidFill>
@@ -8920,8 +8920,8 @@
         </p:nvSpPr>
         <p:spPr>
           <a:xfrm>
-            <a:off x="640080" y="1005840"/>
-            <a:ext cx="457200" cy="274320"/>
+            <a:off x="1097280" y="1920240"/>
+            <a:ext cx="914400" cy="548640"/>
           </a:xfrm>
           <a:prstGeom prst="rect">
             <a:avLst/>
@@ -8956,8 +8956,8 @@
         </p:nvSpPr>
         <p:spPr>
           <a:xfrm>
-            <a:off x="640080" y="1234440"/>
-            <a:ext cx="3749040" cy="228600"/>
+            <a:off x="1097280" y="2148840"/>
+            <a:ext cx="7498080" cy="457200"/>
           </a:xfrm>
           <a:prstGeom prst="rect">
             <a:avLst/>
@@ -8992,8 +8992,8 @@
         </p:nvSpPr>
         <p:spPr>
           <a:xfrm>
-            <a:off x="640080" y="1481328"/>
-            <a:ext cx="3749040" cy="365760"/>
+            <a:off x="1097280" y="2395728"/>
+            <a:ext cx="7498080" cy="731520"/>
           </a:xfrm>
           <a:prstGeom prst="rect">
             <a:avLst/>
@@ -9028,8 +9028,8 @@
         </p:nvSpPr>
         <p:spPr>
           <a:xfrm>
-            <a:off x="4800600" y="914400"/>
-            <a:ext cx="4114800" cy="1005840"/>
+            <a:off x="9601200" y="1828800"/>
+            <a:ext cx="8229600" cy="2011680"/>
           </a:xfrm>
           <a:prstGeom prst="rect">
             <a:avLst/>
@@ -9037,7 +9037,7 @@
           <a:solidFill>
             <a:srgbClr val="FFFFFF"/>
           </a:solidFill>
-          <a:ln w="12700">
+          <a:ln w="25400">
             <a:solidFill>
               <a:srgbClr val="E0E0E0"/>
             </a:solidFill>
@@ -9053,8 +9053,8 @@
         </p:nvSpPr>
         <p:spPr>
           <a:xfrm>
-            <a:off x="4983480" y="1005840"/>
-            <a:ext cx="457200" cy="274320"/>
+            <a:off x="9784080" y="1920240"/>
+            <a:ext cx="914400" cy="548640"/>
           </a:xfrm>
           <a:prstGeom prst="rect">
             <a:avLst/>
@@ -9089,8 +9089,8 @@
         </p:nvSpPr>
         <p:spPr>
           <a:xfrm>
-            <a:off x="4983480" y="1234440"/>
-            <a:ext cx="3749040" cy="228600"/>
+            <a:off x="9784080" y="2148840"/>
+            <a:ext cx="7498080" cy="457200"/>
           </a:xfrm>
           <a:prstGeom prst="rect">
             <a:avLst/>
@@ -9125,8 +9125,8 @@
         </p:nvSpPr>
         <p:spPr>
           <a:xfrm>
-            <a:off x="4983480" y="1481328"/>
-            <a:ext cx="3749040" cy="365760"/>
+            <a:off x="9784080" y="2395728"/>
+            <a:ext cx="7498080" cy="731520"/>
           </a:xfrm>
           <a:prstGeom prst="rect">
             <a:avLst/>
@@ -9161,8 +9161,8 @@
         </p:nvSpPr>
         <p:spPr>
           <a:xfrm>
-            <a:off x="457200" y="2103120"/>
-            <a:ext cx="4114800" cy="1005840"/>
+            <a:off x="914400" y="4206240"/>
+            <a:ext cx="8229600" cy="2011680"/>
           </a:xfrm>
           <a:prstGeom prst="rect">
             <a:avLst/>
@@ -9170,7 +9170,7 @@
           <a:solidFill>
             <a:srgbClr val="FFFFFF"/>
           </a:solidFill>
-          <a:ln w="12700">
+          <a:ln w="25400">
             <a:solidFill>
               <a:srgbClr val="E0E0E0"/>
             </a:solidFill>
@@ -9186,8 +9186,8 @@
         </p:nvSpPr>
         <p:spPr>
           <a:xfrm>
-            <a:off x="640080" y="2194560"/>
-            <a:ext cx="457200" cy="274320"/>
+            <a:off x="1097280" y="4297680"/>
+            <a:ext cx="914400" cy="548640"/>
           </a:xfrm>
           <a:prstGeom prst="rect">
             <a:avLst/>
@@ -9222,8 +9222,8 @@
         </p:nvSpPr>
         <p:spPr>
           <a:xfrm>
-            <a:off x="640080" y="2423160"/>
-            <a:ext cx="3749040" cy="228600"/>
+            <a:off x="1097280" y="4526280"/>
+            <a:ext cx="7498080" cy="457200"/>
           </a:xfrm>
           <a:prstGeom prst="rect">
             <a:avLst/>
@@ -9258,8 +9258,8 @@
         </p:nvSpPr>
         <p:spPr>
           <a:xfrm>
-            <a:off x="640080" y="2670048"/>
-            <a:ext cx="3749040" cy="365760"/>
+            <a:off x="1097280" y="4773168"/>
+            <a:ext cx="7498080" cy="731520"/>
           </a:xfrm>
           <a:prstGeom prst="rect">
             <a:avLst/>
@@ -9294,8 +9294,8 @@
         </p:nvSpPr>
         <p:spPr>
           <a:xfrm>
-            <a:off x="4800600" y="2103120"/>
-            <a:ext cx="4114800" cy="1005840"/>
+            <a:off x="9601200" y="4206240"/>
+            <a:ext cx="8229600" cy="2011680"/>
           </a:xfrm>
           <a:prstGeom prst="rect">
             <a:avLst/>
@@ -9303,7 +9303,7 @@
           <a:solidFill>
             <a:srgbClr val="FFFFFF"/>
           </a:solidFill>
-          <a:ln w="12700">
+          <a:ln w="25400">
             <a:solidFill>
               <a:srgbClr val="E0E0E0"/>
             </a:solidFill>
@@ -9319,8 +9319,8 @@
         </p:nvSpPr>
         <p:spPr>
           <a:xfrm>
-            <a:off x="4983480" y="2194560"/>
-            <a:ext cx="457200" cy="274320"/>
+            <a:off x="9784080" y="4297680"/>
+            <a:ext cx="914400" cy="548640"/>
           </a:xfrm>
           <a:prstGeom prst="rect">
             <a:avLst/>
@@ -9355,8 +9355,8 @@
         </p:nvSpPr>
         <p:spPr>
           <a:xfrm>
-            <a:off x="4983480" y="2423160"/>
-            <a:ext cx="3749040" cy="228600"/>
+            <a:off x="9784080" y="4526280"/>
+            <a:ext cx="7498080" cy="457200"/>
           </a:xfrm>
           <a:prstGeom prst="rect">
             <a:avLst/>
@@ -9391,8 +9391,8 @@
         </p:nvSpPr>
         <p:spPr>
           <a:xfrm>
-            <a:off x="4983480" y="2670048"/>
-            <a:ext cx="3749040" cy="365760"/>
+            <a:off x="9784080" y="4773168"/>
+            <a:ext cx="7498080" cy="731520"/>
           </a:xfrm>
           <a:prstGeom prst="rect">
             <a:avLst/>
@@ -9427,8 +9427,8 @@
         </p:nvSpPr>
         <p:spPr>
           <a:xfrm>
-            <a:off x="914400" y="3383280"/>
-            <a:ext cx="7315200" cy="822960"/>
+            <a:off x="1828800" y="6766560"/>
+            <a:ext cx="14630400" cy="1645920"/>
           </a:xfrm>
           <a:prstGeom prst="rect">
             <a:avLst/>
@@ -9447,8 +9447,8 @@
         </p:nvSpPr>
         <p:spPr>
           <a:xfrm>
-            <a:off x="914400" y="3429000"/>
-            <a:ext cx="7315200" cy="228600"/>
+            <a:off x="1828800" y="6858000"/>
+            <a:ext cx="14630400" cy="457200"/>
           </a:xfrm>
           <a:prstGeom prst="rect">
             <a:avLst/>
@@ -9483,8 +9483,8 @@
         </p:nvSpPr>
         <p:spPr>
           <a:xfrm>
-            <a:off x="914400" y="3703320"/>
-            <a:ext cx="7315200" cy="457200"/>
+            <a:off x="1828800" y="7406640"/>
+            <a:ext cx="14630400" cy="914400"/>
           </a:xfrm>
           <a:prstGeom prst="rect">
             <a:avLst/>
@@ -9566,7 +9566,7 @@
         <p:spPr>
           <a:xfrm>
             <a:off x="0" y="0"/>
-            <a:ext cx="9144000" cy="731520"/>
+            <a:ext cx="18288000" cy="1463040"/>
           </a:xfrm>
           <a:prstGeom prst="rect">
             <a:avLst/>
@@ -9585,8 +9585,8 @@
         </p:nvSpPr>
         <p:spPr>
           <a:xfrm>
-            <a:off x="457200" y="182880"/>
-            <a:ext cx="8229600" cy="365760"/>
+            <a:off x="914400" y="365760"/>
+            <a:ext cx="16459200" cy="731520"/>
           </a:xfrm>
           <a:prstGeom prst="rect">
             <a:avLst/>
@@ -9621,8 +9621,8 @@
         </p:nvSpPr>
         <p:spPr>
           <a:xfrm>
-            <a:off x="457200" y="914400"/>
-            <a:ext cx="4114800" cy="640080"/>
+            <a:off x="914400" y="1828800"/>
+            <a:ext cx="8229600" cy="1280160"/>
           </a:xfrm>
           <a:prstGeom prst="rect">
             <a:avLst/>
@@ -9630,7 +9630,7 @@
           <a:solidFill>
             <a:srgbClr val="FFFFFF"/>
           </a:solidFill>
-          <a:ln w="38100">
+          <a:ln w="76200">
             <a:solidFill>
               <a:srgbClr val="D4AF37"/>
             </a:solidFill>
@@ -9646,8 +9646,8 @@
         </p:nvSpPr>
         <p:spPr>
           <a:xfrm>
-            <a:off x="640080" y="960120"/>
-            <a:ext cx="3749040" cy="320040"/>
+            <a:off x="1280160" y="1920240"/>
+            <a:ext cx="7498080" cy="640080"/>
           </a:xfrm>
           <a:prstGeom prst="rect">
             <a:avLst/>
@@ -9682,8 +9682,8 @@
         </p:nvSpPr>
         <p:spPr>
           <a:xfrm>
-            <a:off x="640080" y="1298448"/>
-            <a:ext cx="3749040" cy="182880"/>
+            <a:off x="1280160" y="2596896"/>
+            <a:ext cx="7498080" cy="365760"/>
           </a:xfrm>
           <a:prstGeom prst="rect">
             <a:avLst/>
@@ -9718,8 +9718,8 @@
         </p:nvSpPr>
         <p:spPr>
           <a:xfrm>
-            <a:off x="457200" y="1691640"/>
-            <a:ext cx="4114800" cy="640080"/>
+            <a:off x="914400" y="3383280"/>
+            <a:ext cx="8229600" cy="1280160"/>
           </a:xfrm>
           <a:prstGeom prst="rect">
             <a:avLst/>
@@ -9727,7 +9727,7 @@
           <a:solidFill>
             <a:srgbClr val="FFFFFF"/>
           </a:solidFill>
-          <a:ln w="38100">
+          <a:ln w="76200">
             <a:solidFill>
               <a:srgbClr val="D4AF37"/>
             </a:solidFill>
@@ -9743,8 +9743,8 @@
         </p:nvSpPr>
         <p:spPr>
           <a:xfrm>
-            <a:off x="640080" y="1737360"/>
-            <a:ext cx="3749040" cy="320040"/>
+            <a:off x="1280160" y="3474720"/>
+            <a:ext cx="7498080" cy="640080"/>
           </a:xfrm>
           <a:prstGeom prst="rect">
             <a:avLst/>
@@ -9779,8 +9779,8 @@
         </p:nvSpPr>
         <p:spPr>
           <a:xfrm>
-            <a:off x="640080" y="2075688"/>
-            <a:ext cx="3749040" cy="182880"/>
+            <a:off x="1280160" y="4151376"/>
+            <a:ext cx="7498080" cy="365760"/>
           </a:xfrm>
           <a:prstGeom prst="rect">
             <a:avLst/>
@@ -9815,8 +9815,8 @@
         </p:nvSpPr>
         <p:spPr>
           <a:xfrm>
-            <a:off x="4800600" y="914400"/>
-            <a:ext cx="3886200" cy="777240"/>
+            <a:off x="9601200" y="1828800"/>
+            <a:ext cx="7772400" cy="1554480"/>
           </a:xfrm>
           <a:prstGeom prst="rect">
             <a:avLst/>
@@ -9824,7 +9824,7 @@
           <a:solidFill>
             <a:srgbClr val="D4EDDA"/>
           </a:solidFill>
-          <a:ln w="38100">
+          <a:ln w="76200">
             <a:solidFill>
               <a:srgbClr val="28A745"/>
             </a:solidFill>
@@ -9840,8 +9840,8 @@
         </p:nvSpPr>
         <p:spPr>
           <a:xfrm>
-            <a:off x="4983480" y="1005840"/>
-            <a:ext cx="3520440" cy="228600"/>
+            <a:off x="9966960" y="1920240"/>
+            <a:ext cx="7040880" cy="457200"/>
           </a:xfrm>
           <a:prstGeom prst="rect">
             <a:avLst/>
@@ -9876,8 +9876,8 @@
         </p:nvSpPr>
         <p:spPr>
           <a:xfrm>
-            <a:off x="4983480" y="1261872"/>
-            <a:ext cx="3520440" cy="365760"/>
+            <a:off x="9966960" y="2176272"/>
+            <a:ext cx="7040880" cy="731520"/>
           </a:xfrm>
           <a:prstGeom prst="rect">
             <a:avLst/>
@@ -9912,8 +9912,8 @@
         </p:nvSpPr>
         <p:spPr>
           <a:xfrm>
-            <a:off x="4800600" y="1828800"/>
-            <a:ext cx="3886200" cy="777240"/>
+            <a:off x="9601200" y="3657600"/>
+            <a:ext cx="7772400" cy="1554480"/>
           </a:xfrm>
           <a:prstGeom prst="rect">
             <a:avLst/>
@@ -9921,7 +9921,7 @@
           <a:solidFill>
             <a:srgbClr val="D4EDDA"/>
           </a:solidFill>
-          <a:ln w="38100">
+          <a:ln w="76200">
             <a:solidFill>
               <a:srgbClr val="28A745"/>
             </a:solidFill>
@@ -9937,8 +9937,8 @@
         </p:nvSpPr>
         <p:spPr>
           <a:xfrm>
-            <a:off x="4983480" y="1920240"/>
-            <a:ext cx="3520440" cy="228600"/>
+            <a:off x="9966960" y="3749040"/>
+            <a:ext cx="7040880" cy="457200"/>
           </a:xfrm>
           <a:prstGeom prst="rect">
             <a:avLst/>
@@ -9973,8 +9973,8 @@
         </p:nvSpPr>
         <p:spPr>
           <a:xfrm>
-            <a:off x="4983480" y="2176272"/>
-            <a:ext cx="3520440" cy="365760"/>
+            <a:off x="9966960" y="4005072"/>
+            <a:ext cx="7040880" cy="731520"/>
           </a:xfrm>
           <a:prstGeom prst="rect">
             <a:avLst/>
@@ -10009,8 +10009,8 @@
         </p:nvSpPr>
         <p:spPr>
           <a:xfrm>
-            <a:off x="4800600" y="2743200"/>
-            <a:ext cx="3886200" cy="777240"/>
+            <a:off x="9601200" y="5486400"/>
+            <a:ext cx="7772400" cy="1554480"/>
           </a:xfrm>
           <a:prstGeom prst="rect">
             <a:avLst/>
@@ -10018,7 +10018,7 @@
           <a:solidFill>
             <a:srgbClr val="D4EDDA"/>
           </a:solidFill>
-          <a:ln w="38100">
+          <a:ln w="76200">
             <a:solidFill>
               <a:srgbClr val="28A745"/>
             </a:solidFill>
@@ -10034,8 +10034,8 @@
         </p:nvSpPr>
         <p:spPr>
           <a:xfrm>
-            <a:off x="4983480" y="2834640"/>
-            <a:ext cx="3520440" cy="228600"/>
+            <a:off x="9966960" y="5577840"/>
+            <a:ext cx="7040880" cy="457200"/>
           </a:xfrm>
           <a:prstGeom prst="rect">
             <a:avLst/>
@@ -10070,8 +10070,8 @@
         </p:nvSpPr>
         <p:spPr>
           <a:xfrm>
-            <a:off x="4983480" y="3090672"/>
-            <a:ext cx="3520440" cy="365760"/>
+            <a:off x="9966960" y="5833872"/>
+            <a:ext cx="7040880" cy="731520"/>
           </a:xfrm>
           <a:prstGeom prst="rect">
             <a:avLst/>
@@ -10139,7 +10139,7 @@
         <p:spPr>
           <a:xfrm>
             <a:off x="0" y="0"/>
-            <a:ext cx="9144000" cy="685800"/>
+            <a:ext cx="18288000" cy="1371600"/>
           </a:xfrm>
           <a:prstGeom prst="rect">
             <a:avLst/>
@@ -10158,8 +10158,8 @@
         </p:nvSpPr>
         <p:spPr>
           <a:xfrm>
-            <a:off x="457200" y="164592"/>
-            <a:ext cx="8229600" cy="365760"/>
+            <a:off x="914400" y="329184"/>
+            <a:ext cx="16459200" cy="731520"/>
           </a:xfrm>
           <a:prstGeom prst="rect">
             <a:avLst/>
@@ -10194,8 +10194,8 @@
         </p:nvSpPr>
         <p:spPr>
           <a:xfrm>
-            <a:off x="457200" y="868680"/>
-            <a:ext cx="5943600" cy="548640"/>
+            <a:off x="914400" y="1737360"/>
+            <a:ext cx="11887200" cy="1097280"/>
           </a:xfrm>
           <a:prstGeom prst="rect">
             <a:avLst/>
@@ -10203,7 +10203,7 @@
           <a:solidFill>
             <a:srgbClr val="FFFFFF"/>
           </a:solidFill>
-          <a:ln w="25400">
+          <a:ln w="50800">
             <a:solidFill>
               <a:srgbClr val="003366"/>
             </a:solidFill>
@@ -10219,8 +10219,8 @@
         </p:nvSpPr>
         <p:spPr>
           <a:xfrm>
-            <a:off x="594360" y="914400"/>
-            <a:ext cx="4114800" cy="182880"/>
+            <a:off x="1188720" y="1783080"/>
+            <a:ext cx="8229600" cy="365760"/>
           </a:xfrm>
           <a:prstGeom prst="rect">
             <a:avLst/>
@@ -10255,8 +10255,8 @@
         </p:nvSpPr>
         <p:spPr>
           <a:xfrm>
-            <a:off x="594360" y="1115568"/>
-            <a:ext cx="4114800" cy="137160"/>
+            <a:off x="1188720" y="1984248"/>
+            <a:ext cx="8229600" cy="274320"/>
           </a:xfrm>
           <a:prstGeom prst="rect">
             <a:avLst/>
@@ -10291,8 +10291,8 @@
         </p:nvSpPr>
         <p:spPr>
           <a:xfrm>
-            <a:off x="594360" y="1271016"/>
-            <a:ext cx="4114800" cy="109728"/>
+            <a:off x="1188720" y="2139696"/>
+            <a:ext cx="8229600" cy="219456"/>
           </a:xfrm>
           <a:prstGeom prst="rect">
             <a:avLst/>
@@ -10327,8 +10327,8 @@
         </p:nvSpPr>
         <p:spPr>
           <a:xfrm>
-            <a:off x="5303520" y="1051560"/>
-            <a:ext cx="914400" cy="182880"/>
+            <a:off x="10607040" y="1920240"/>
+            <a:ext cx="1828800" cy="365760"/>
           </a:xfrm>
           <a:prstGeom prst="rect">
             <a:avLst/>
@@ -10347,8 +10347,8 @@
         </p:nvSpPr>
         <p:spPr>
           <a:xfrm>
-            <a:off x="5303520" y="1051560"/>
-            <a:ext cx="914400" cy="182880"/>
+            <a:off x="10607040" y="1920240"/>
+            <a:ext cx="1828800" cy="365760"/>
           </a:xfrm>
           <a:prstGeom prst="rect">
             <a:avLst/>
@@ -10383,8 +10383,8 @@
         </p:nvSpPr>
         <p:spPr>
           <a:xfrm>
-            <a:off x="2926080" y="1435608"/>
-            <a:ext cx="548640" cy="228600"/>
+            <a:off x="5852160" y="2304288"/>
+            <a:ext cx="1097280" cy="457200"/>
           </a:xfrm>
           <a:prstGeom prst="rect">
             <a:avLst/>
@@ -10419,8 +10419,8 @@
         </p:nvSpPr>
         <p:spPr>
           <a:xfrm>
-            <a:off x="457200" y="1508760"/>
-            <a:ext cx="5943600" cy="548640"/>
+            <a:off x="914400" y="3017520"/>
+            <a:ext cx="11887200" cy="1097280"/>
           </a:xfrm>
           <a:prstGeom prst="rect">
             <a:avLst/>
@@ -10428,7 +10428,7 @@
           <a:solidFill>
             <a:srgbClr val="FFFFFF"/>
           </a:solidFill>
-          <a:ln w="25400">
+          <a:ln w="50800">
             <a:solidFill>
               <a:srgbClr val="003366"/>
             </a:solidFill>
@@ -10444,8 +10444,8 @@
         </p:nvSpPr>
         <p:spPr>
           <a:xfrm>
-            <a:off x="594360" y="1554480"/>
-            <a:ext cx="4114800" cy="182880"/>
+            <a:off x="1188720" y="3063240"/>
+            <a:ext cx="8229600" cy="365760"/>
           </a:xfrm>
           <a:prstGeom prst="rect">
             <a:avLst/>
@@ -10480,8 +10480,8 @@
         </p:nvSpPr>
         <p:spPr>
           <a:xfrm>
-            <a:off x="594360" y="1755648"/>
-            <a:ext cx="4114800" cy="137160"/>
+            <a:off x="1188720" y="3264408"/>
+            <a:ext cx="8229600" cy="274320"/>
           </a:xfrm>
           <a:prstGeom prst="rect">
             <a:avLst/>
@@ -10516,8 +10516,8 @@
         </p:nvSpPr>
         <p:spPr>
           <a:xfrm>
-            <a:off x="594360" y="1911096"/>
-            <a:ext cx="4114800" cy="109728"/>
+            <a:off x="1188720" y="3419856"/>
+            <a:ext cx="8229600" cy="219456"/>
           </a:xfrm>
           <a:prstGeom prst="rect">
             <a:avLst/>
@@ -10552,8 +10552,8 @@
         </p:nvSpPr>
         <p:spPr>
           <a:xfrm>
-            <a:off x="5303520" y="1691640"/>
-            <a:ext cx="914400" cy="182880"/>
+            <a:off x="10607040" y="3200400"/>
+            <a:ext cx="1828800" cy="365760"/>
           </a:xfrm>
           <a:prstGeom prst="rect">
             <a:avLst/>
@@ -10572,8 +10572,8 @@
         </p:nvSpPr>
         <p:spPr>
           <a:xfrm>
-            <a:off x="5303520" y="1691640"/>
-            <a:ext cx="914400" cy="182880"/>
+            <a:off x="10607040" y="3200400"/>
+            <a:ext cx="1828800" cy="365760"/>
           </a:xfrm>
           <a:prstGeom prst="rect">
             <a:avLst/>
@@ -10608,8 +10608,8 @@
         </p:nvSpPr>
         <p:spPr>
           <a:xfrm>
-            <a:off x="2926080" y="2075688"/>
-            <a:ext cx="548640" cy="228600"/>
+            <a:off x="5852160" y="3584448"/>
+            <a:ext cx="1097280" cy="457200"/>
           </a:xfrm>
           <a:prstGeom prst="rect">
             <a:avLst/>
@@ -10644,8 +10644,8 @@
         </p:nvSpPr>
         <p:spPr>
           <a:xfrm>
-            <a:off x="457200" y="2148840"/>
-            <a:ext cx="5943600" cy="548640"/>
+            <a:off x="914400" y="4297680"/>
+            <a:ext cx="11887200" cy="1097280"/>
           </a:xfrm>
           <a:prstGeom prst="rect">
             <a:avLst/>
@@ -10653,7 +10653,7 @@
           <a:solidFill>
             <a:srgbClr val="FFFFFF"/>
           </a:solidFill>
-          <a:ln w="25400">
+          <a:ln w="50800">
             <a:solidFill>
               <a:srgbClr val="003366"/>
             </a:solidFill>
@@ -10669,8 +10669,8 @@
         </p:nvSpPr>
         <p:spPr>
           <a:xfrm>
-            <a:off x="594360" y="2194560"/>
-            <a:ext cx="4114800" cy="182880"/>
+            <a:off x="1188720" y="4343400"/>
+            <a:ext cx="8229600" cy="365760"/>
           </a:xfrm>
           <a:prstGeom prst="rect">
             <a:avLst/>
@@ -10705,8 +10705,8 @@
         </p:nvSpPr>
         <p:spPr>
           <a:xfrm>
-            <a:off x="594360" y="2395728"/>
-            <a:ext cx="4114800" cy="137160"/>
+            <a:off x="1188720" y="4544568"/>
+            <a:ext cx="8229600" cy="274320"/>
           </a:xfrm>
           <a:prstGeom prst="rect">
             <a:avLst/>
@@ -10741,8 +10741,8 @@
         </p:nvSpPr>
         <p:spPr>
           <a:xfrm>
-            <a:off x="594360" y="2551176"/>
-            <a:ext cx="4114800" cy="109728"/>
+            <a:off x="1188720" y="4700016"/>
+            <a:ext cx="8229600" cy="219456"/>
           </a:xfrm>
           <a:prstGeom prst="rect">
             <a:avLst/>
@@ -10777,8 +10777,8 @@
         </p:nvSpPr>
         <p:spPr>
           <a:xfrm>
-            <a:off x="5303520" y="2331720"/>
-            <a:ext cx="914400" cy="182880"/>
+            <a:off x="10607040" y="4480560"/>
+            <a:ext cx="1828800" cy="365760"/>
           </a:xfrm>
           <a:prstGeom prst="rect">
             <a:avLst/>
@@ -10797,8 +10797,8 @@
         </p:nvSpPr>
         <p:spPr>
           <a:xfrm>
-            <a:off x="5303520" y="2331720"/>
-            <a:ext cx="914400" cy="182880"/>
+            <a:off x="10607040" y="4480560"/>
+            <a:ext cx="1828800" cy="365760"/>
           </a:xfrm>
           <a:prstGeom prst="rect">
             <a:avLst/>
@@ -10833,8 +10833,8 @@
         </p:nvSpPr>
         <p:spPr>
           <a:xfrm>
-            <a:off x="2926080" y="2715768"/>
-            <a:ext cx="548640" cy="228600"/>
+            <a:off x="5852160" y="4864608"/>
+            <a:ext cx="1097280" cy="457200"/>
           </a:xfrm>
           <a:prstGeom prst="rect">
             <a:avLst/>
@@ -10869,8 +10869,8 @@
         </p:nvSpPr>
         <p:spPr>
           <a:xfrm>
-            <a:off x="457200" y="2788920"/>
-            <a:ext cx="5943600" cy="548640"/>
+            <a:off x="914400" y="5577840"/>
+            <a:ext cx="11887200" cy="1097280"/>
           </a:xfrm>
           <a:prstGeom prst="rect">
             <a:avLst/>
@@ -10878,7 +10878,7 @@
           <a:solidFill>
             <a:srgbClr val="FFFFFF"/>
           </a:solidFill>
-          <a:ln w="25400">
+          <a:ln w="50800">
             <a:solidFill>
               <a:srgbClr val="003366"/>
             </a:solidFill>
@@ -10894,8 +10894,8 @@
         </p:nvSpPr>
         <p:spPr>
           <a:xfrm>
-            <a:off x="594360" y="2834640"/>
-            <a:ext cx="4114800" cy="182880"/>
+            <a:off x="1188720" y="5623560"/>
+            <a:ext cx="8229600" cy="365760"/>
           </a:xfrm>
           <a:prstGeom prst="rect">
             <a:avLst/>
@@ -10930,8 +10930,8 @@
         </p:nvSpPr>
         <p:spPr>
           <a:xfrm>
-            <a:off x="594360" y="3035808"/>
-            <a:ext cx="4114800" cy="137160"/>
+            <a:off x="1188720" y="5824728"/>
+            <a:ext cx="8229600" cy="274320"/>
           </a:xfrm>
           <a:prstGeom prst="rect">
             <a:avLst/>
@@ -10966,8 +10966,8 @@
         </p:nvSpPr>
         <p:spPr>
           <a:xfrm>
-            <a:off x="594360" y="3191256"/>
-            <a:ext cx="4114800" cy="109728"/>
+            <a:off x="1188720" y="5980176"/>
+            <a:ext cx="8229600" cy="219456"/>
           </a:xfrm>
           <a:prstGeom prst="rect">
             <a:avLst/>
@@ -11002,8 +11002,8 @@
         </p:nvSpPr>
         <p:spPr>
           <a:xfrm>
-            <a:off x="5303520" y="2971800"/>
-            <a:ext cx="914400" cy="182880"/>
+            <a:off x="10607040" y="5760720"/>
+            <a:ext cx="1828800" cy="365760"/>
           </a:xfrm>
           <a:prstGeom prst="rect">
             <a:avLst/>
@@ -11022,8 +11022,8 @@
         </p:nvSpPr>
         <p:spPr>
           <a:xfrm>
-            <a:off x="5303520" y="2971800"/>
-            <a:ext cx="914400" cy="182880"/>
+            <a:off x="10607040" y="5760720"/>
+            <a:ext cx="1828800" cy="365760"/>
           </a:xfrm>
           <a:prstGeom prst="rect">
             <a:avLst/>
@@ -11058,8 +11058,8 @@
         </p:nvSpPr>
         <p:spPr>
           <a:xfrm>
-            <a:off x="2926080" y="3355848"/>
-            <a:ext cx="548640" cy="228600"/>
+            <a:off x="5852160" y="6144768"/>
+            <a:ext cx="1097280" cy="457200"/>
           </a:xfrm>
           <a:prstGeom prst="rect">
             <a:avLst/>
@@ -11094,8 +11094,8 @@
         </p:nvSpPr>
         <p:spPr>
           <a:xfrm>
-            <a:off x="457200" y="3429000"/>
-            <a:ext cx="5943600" cy="548640"/>
+            <a:off x="914400" y="6858000"/>
+            <a:ext cx="11887200" cy="1097280"/>
           </a:xfrm>
           <a:prstGeom prst="rect">
             <a:avLst/>
@@ -11103,7 +11103,7 @@
           <a:solidFill>
             <a:srgbClr val="FFFFFF"/>
           </a:solidFill>
-          <a:ln w="25400">
+          <a:ln w="50800">
             <a:solidFill>
               <a:srgbClr val="003366"/>
             </a:solidFill>
@@ -11119,8 +11119,8 @@
         </p:nvSpPr>
         <p:spPr>
           <a:xfrm>
-            <a:off x="594360" y="3474720"/>
-            <a:ext cx="4114800" cy="182880"/>
+            <a:off x="1188720" y="6903720"/>
+            <a:ext cx="8229600" cy="365760"/>
           </a:xfrm>
           <a:prstGeom prst="rect">
             <a:avLst/>
@@ -11155,8 +11155,8 @@
         </p:nvSpPr>
         <p:spPr>
           <a:xfrm>
-            <a:off x="594360" y="3675888"/>
-            <a:ext cx="4114800" cy="137160"/>
+            <a:off x="1188720" y="7104888"/>
+            <a:ext cx="8229600" cy="274320"/>
           </a:xfrm>
           <a:prstGeom prst="rect">
             <a:avLst/>
@@ -11191,8 +11191,8 @@
         </p:nvSpPr>
         <p:spPr>
           <a:xfrm>
-            <a:off x="594360" y="3831336"/>
-            <a:ext cx="4114800" cy="109728"/>
+            <a:off x="1188720" y="7260336"/>
+            <a:ext cx="8229600" cy="219456"/>
           </a:xfrm>
           <a:prstGeom prst="rect">
             <a:avLst/>
@@ -11227,8 +11227,8 @@
         </p:nvSpPr>
         <p:spPr>
           <a:xfrm>
-            <a:off x="5303520" y="3611880"/>
-            <a:ext cx="914400" cy="182880"/>
+            <a:off x="10607040" y="7040880"/>
+            <a:ext cx="1828800" cy="365760"/>
           </a:xfrm>
           <a:prstGeom prst="rect">
             <a:avLst/>
@@ -11247,8 +11247,8 @@
         </p:nvSpPr>
         <p:spPr>
           <a:xfrm>
-            <a:off x="5303520" y="3611880"/>
-            <a:ext cx="914400" cy="182880"/>
+            <a:off x="10607040" y="7040880"/>
+            <a:ext cx="1828800" cy="365760"/>
           </a:xfrm>
           <a:prstGeom prst="rect">
             <a:avLst/>
@@ -11283,8 +11283,8 @@
         </p:nvSpPr>
         <p:spPr>
           <a:xfrm>
-            <a:off x="6583680" y="914400"/>
-            <a:ext cx="2103120" cy="731520"/>
+            <a:off x="13167360" y="1828800"/>
+            <a:ext cx="4206240" cy="1463040"/>
           </a:xfrm>
           <a:prstGeom prst="rect">
             <a:avLst/>
@@ -11303,8 +11303,8 @@
         </p:nvSpPr>
         <p:spPr>
           <a:xfrm>
-            <a:off x="6583680" y="960120"/>
-            <a:ext cx="2103120" cy="228600"/>
+            <a:off x="13167360" y="1920240"/>
+            <a:ext cx="4206240" cy="457200"/>
           </a:xfrm>
           <a:prstGeom prst="rect">
             <a:avLst/>
@@ -11339,8 +11339,8 @@
         </p:nvSpPr>
         <p:spPr>
           <a:xfrm>
-            <a:off x="6583680" y="1207008"/>
-            <a:ext cx="2103120" cy="365760"/>
+            <a:off x="13167360" y="2414016"/>
+            <a:ext cx="4206240" cy="731520"/>
           </a:xfrm>
           <a:prstGeom prst="rect">
             <a:avLst/>
@@ -11408,7 +11408,7 @@
         <p:spPr>
           <a:xfrm>
             <a:off x="0" y="0"/>
-            <a:ext cx="9144000" cy="731520"/>
+            <a:ext cx="18288000" cy="1463040"/>
           </a:xfrm>
           <a:prstGeom prst="rect">
             <a:avLst/>
@@ -11427,8 +11427,8 @@
         </p:nvSpPr>
         <p:spPr>
           <a:xfrm>
-            <a:off x="457200" y="182880"/>
-            <a:ext cx="8229600" cy="365760"/>
+            <a:off x="914400" y="365760"/>
+            <a:ext cx="16459200" cy="731520"/>
           </a:xfrm>
           <a:prstGeom prst="rect">
             <a:avLst/>
@@ -11463,8 +11463,8 @@
         </p:nvSpPr>
         <p:spPr>
           <a:xfrm>
-            <a:off x="457200" y="914400"/>
-            <a:ext cx="4114800" cy="274320"/>
+            <a:off x="914400" y="1828800"/>
+            <a:ext cx="8229600" cy="548640"/>
           </a:xfrm>
           <a:prstGeom prst="rect">
             <a:avLst/>
@@ -11499,8 +11499,8 @@
         </p:nvSpPr>
         <p:spPr>
           <a:xfrm>
-            <a:off x="640080" y="1280160"/>
-            <a:ext cx="3657600" cy="320040"/>
+            <a:off x="1280160" y="2560320"/>
+            <a:ext cx="7315200" cy="640080"/>
           </a:xfrm>
           <a:prstGeom prst="rect">
             <a:avLst/>
@@ -11535,8 +11535,8 @@
         </p:nvSpPr>
         <p:spPr>
           <a:xfrm>
-            <a:off x="640080" y="1645920"/>
-            <a:ext cx="3657600" cy="320040"/>
+            <a:off x="1280160" y="2926080"/>
+            <a:ext cx="7315200" cy="640080"/>
           </a:xfrm>
           <a:prstGeom prst="rect">
             <a:avLst/>
@@ -11571,8 +11571,8 @@
         </p:nvSpPr>
         <p:spPr>
           <a:xfrm>
-            <a:off x="640080" y="2011680"/>
-            <a:ext cx="3657600" cy="320040"/>
+            <a:off x="1280160" y="3291840"/>
+            <a:ext cx="7315200" cy="640080"/>
           </a:xfrm>
           <a:prstGeom prst="rect">
             <a:avLst/>
@@ -11607,8 +11607,8 @@
         </p:nvSpPr>
         <p:spPr>
           <a:xfrm>
-            <a:off x="640080" y="2377440"/>
-            <a:ext cx="3657600" cy="320040"/>
+            <a:off x="1280160" y="3657600"/>
+            <a:ext cx="7315200" cy="640080"/>
           </a:xfrm>
           <a:prstGeom prst="rect">
             <a:avLst/>
@@ -11643,8 +11643,8 @@
         </p:nvSpPr>
         <p:spPr>
           <a:xfrm>
-            <a:off x="4800600" y="914400"/>
-            <a:ext cx="3886200" cy="1097280"/>
+            <a:off x="9601200" y="1828800"/>
+            <a:ext cx="7772400" cy="2194560"/>
           </a:xfrm>
           <a:prstGeom prst="rect">
             <a:avLst/>
@@ -11652,7 +11652,7 @@
           <a:solidFill>
             <a:srgbClr val="D4EDDA"/>
           </a:solidFill>
-          <a:ln w="25400">
+          <a:ln w="50800">
             <a:solidFill>
               <a:srgbClr val="28A745"/>
             </a:solidFill>
@@ -11668,8 +11668,8 @@
         </p:nvSpPr>
         <p:spPr>
           <a:xfrm>
-            <a:off x="4983480" y="1005840"/>
-            <a:ext cx="3520440" cy="228600"/>
+            <a:off x="9966960" y="2011680"/>
+            <a:ext cx="7040880" cy="457200"/>
           </a:xfrm>
           <a:prstGeom prst="rect">
             <a:avLst/>
@@ -11704,8 +11704,8 @@
         </p:nvSpPr>
         <p:spPr>
           <a:xfrm>
-            <a:off x="4983480" y="1280160"/>
-            <a:ext cx="3520440" cy="640080"/>
+            <a:off x="9966960" y="2560320"/>
+            <a:ext cx="7040880" cy="1280160"/>
           </a:xfrm>
           <a:prstGeom prst="rect">
             <a:avLst/>
@@ -11768,8 +11768,8 @@
         </p:nvSpPr>
         <p:spPr>
           <a:xfrm>
-            <a:off x="4983480" y="2286000"/>
-            <a:ext cx="3520440" cy="457200"/>
+            <a:off x="9966960" y="4572000"/>
+            <a:ext cx="7040880" cy="914400"/>
           </a:xfrm>
           <a:prstGeom prst="rect">
             <a:avLst/>
@@ -11851,7 +11851,7 @@
         <p:spPr>
           <a:xfrm>
             <a:off x="0" y="0"/>
-            <a:ext cx="9144000" cy="731520"/>
+            <a:ext cx="18288000" cy="1463040"/>
           </a:xfrm>
           <a:prstGeom prst="rect">
             <a:avLst/>
@@ -11870,8 +11870,8 @@
         </p:nvSpPr>
         <p:spPr>
           <a:xfrm>
-            <a:off x="457200" y="182880"/>
-            <a:ext cx="8229600" cy="365760"/>
+            <a:off x="914400" y="365760"/>
+            <a:ext cx="16459200" cy="731520"/>
           </a:xfrm>
           <a:prstGeom prst="rect">
             <a:avLst/>
@@ -11906,8 +11906,8 @@
         </p:nvSpPr>
         <p:spPr>
           <a:xfrm>
-            <a:off x="457200" y="914400"/>
-            <a:ext cx="8229600" cy="1371600"/>
+            <a:off x="914400" y="1828800"/>
+            <a:ext cx="16459200" cy="2743200"/>
           </a:xfrm>
           <a:prstGeom prst="rect">
             <a:avLst/>
@@ -11915,7 +11915,7 @@
           <a:solidFill>
             <a:srgbClr val="FFFFFF"/>
           </a:solidFill>
-          <a:ln w="25400">
+          <a:ln w="50800">
             <a:solidFill>
               <a:srgbClr val="003366"/>
             </a:solidFill>
@@ -11931,8 +11931,8 @@
         </p:nvSpPr>
         <p:spPr>
           <a:xfrm>
-            <a:off x="640080" y="1005840"/>
-            <a:ext cx="7863840" cy="274320"/>
+            <a:off x="1280160" y="2011680"/>
+            <a:ext cx="15727680" cy="548640"/>
           </a:xfrm>
           <a:prstGeom prst="rect">
             <a:avLst/>
@@ -11967,8 +11967,8 @@
         </p:nvSpPr>
         <p:spPr>
           <a:xfrm>
-            <a:off x="640080" y="1325880"/>
-            <a:ext cx="5486400" cy="868680"/>
+            <a:off x="1280160" y="2651760"/>
+            <a:ext cx="10972800" cy="1737360"/>
           </a:xfrm>
           <a:prstGeom prst="rect">
             <a:avLst/>
@@ -12051,8 +12051,8 @@
         </p:nvSpPr>
         <p:spPr>
           <a:xfrm>
-            <a:off x="457200" y="2468880"/>
-            <a:ext cx="8229600" cy="1554480"/>
+            <a:off x="914400" y="4937760"/>
+            <a:ext cx="16459200" cy="3108960"/>
           </a:xfrm>
           <a:prstGeom prst="rect">
             <a:avLst/>
@@ -12060,7 +12060,7 @@
           <a:solidFill>
             <a:srgbClr val="FFFFFF"/>
           </a:solidFill>
-          <a:ln w="25400">
+          <a:ln w="50800">
             <a:solidFill>
               <a:srgbClr val="003366"/>
             </a:solidFill>
@@ -12076,8 +12076,8 @@
         </p:nvSpPr>
         <p:spPr>
           <a:xfrm>
-            <a:off x="640080" y="2560320"/>
-            <a:ext cx="7863840" cy="274320"/>
+            <a:off x="1280160" y="5120640"/>
+            <a:ext cx="15727680" cy="548640"/>
           </a:xfrm>
           <a:prstGeom prst="rect">
             <a:avLst/>
@@ -12112,8 +12112,8 @@
         </p:nvSpPr>
         <p:spPr>
           <a:xfrm>
-            <a:off x="640080" y="2880360"/>
-            <a:ext cx="5486400" cy="1051560"/>
+            <a:off x="1280160" y="5760720"/>
+            <a:ext cx="10972800" cy="2103120"/>
           </a:xfrm>
           <a:prstGeom prst="rect">
             <a:avLst/>
@@ -12243,7 +12243,7 @@
         <p:spPr>
           <a:xfrm>
             <a:off x="0" y="0"/>
-            <a:ext cx="9144000" cy="731520"/>
+            <a:ext cx="18288000" cy="1463040"/>
           </a:xfrm>
           <a:prstGeom prst="rect">
             <a:avLst/>
@@ -12262,8 +12262,8 @@
         </p:nvSpPr>
         <p:spPr>
           <a:xfrm>
-            <a:off x="457200" y="182880"/>
-            <a:ext cx="8229600" cy="365760"/>
+            <a:off x="914400" y="365760"/>
+            <a:ext cx="16459200" cy="731520"/>
           </a:xfrm>
           <a:prstGeom prst="rect">
             <a:avLst/>
@@ -12298,8 +12298,8 @@
         </p:nvSpPr>
         <p:spPr>
           <a:xfrm>
-            <a:off x="1371600" y="914400"/>
-            <a:ext cx="6400800" cy="640080"/>
+            <a:off x="2743200" y="1828800"/>
+            <a:ext cx="12801600" cy="1280160"/>
           </a:xfrm>
           <a:prstGeom prst="rect">
             <a:avLst/>
@@ -12318,8 +12318,8 @@
         </p:nvSpPr>
         <p:spPr>
           <a:xfrm>
-            <a:off x="1371600" y="1005840"/>
-            <a:ext cx="6400800" cy="320040"/>
+            <a:off x="2743200" y="2011680"/>
+            <a:ext cx="12801600" cy="640080"/>
           </a:xfrm>
           <a:prstGeom prst="rect">
             <a:avLst/>
@@ -12354,8 +12354,8 @@
         </p:nvSpPr>
         <p:spPr>
           <a:xfrm>
-            <a:off x="1371600" y="1325880"/>
-            <a:ext cx="6400800" cy="182880"/>
+            <a:off x="2743200" y="2651760"/>
+            <a:ext cx="12801600" cy="365760"/>
           </a:xfrm>
           <a:prstGeom prst="rect">
             <a:avLst/>
@@ -12390,8 +12390,8 @@
         </p:nvSpPr>
         <p:spPr>
           <a:xfrm>
-            <a:off x="640080" y="1828800"/>
-            <a:ext cx="7863840" cy="2194560"/>
+            <a:off x="1280160" y="3657600"/>
+            <a:ext cx="15727680" cy="4389120"/>
           </a:xfrm>
           <a:prstGeom prst="rect">
             <a:avLst/>

</xml_diff>